<commit_message>
fix(submission): correct slide figures, real dashboard link, raw-data sheet in Excel
Co-Authored-By: Claude Opus 5.5 <noreply@anthropic.com>
</commit_message>
<xml_diff>
--- a/Presentasi_DSS_BBPP_Ketindan.pptx
+++ b/Presentasi_DSS_BBPP_Ketindan.pptx
@@ -3336,7 +3336,7 @@
       </p:sp>
       <p:sp>
         <p:nvSpPr>
-          <p:cNvPr id="4" name="Rounded Rectangle 3"/>
+          <p:cNvPr id="4" name="Rectangle 3"/>
           <p:cNvSpPr/>
           <p:nvPr/>
         </p:nvSpPr>
@@ -3345,15 +3345,15 @@
             <a:off x="731520" y="1554480"/>
             <a:ext cx="5120640" cy="4846320"/>
           </a:xfrm>
-          <a:prstGeom prst="roundRect">
+          <a:prstGeom prst="rect">
             <a:avLst/>
           </a:prstGeom>
           <a:solidFill>
-            <a:srgbClr val="FFFFFF"/>
+            <a:srgbClr val="F8F9FA"/>
           </a:solidFill>
-          <a:ln w="19050">
+          <a:ln w="9525">
             <a:solidFill>
-              <a:srgbClr val="35865B"/>
+              <a:srgbClr val="DEE2E6"/>
             </a:solidFill>
           </a:ln>
         </p:spPr>
@@ -3381,108 +3381,23 @@
       </p:sp>
       <p:sp>
         <p:nvSpPr>
-          <p:cNvPr id="5" name="TextBox 4"/>
-          <p:cNvSpPr txBox="1"/>
-          <p:nvPr/>
-        </p:nvSpPr>
-        <p:spPr>
-          <a:xfrm>
-            <a:off x="932688" y="1719072"/>
-            <a:ext cx="4718304" cy="4517136"/>
-          </a:xfrm>
-          <a:prstGeom prst="rect">
-            <a:avLst/>
-          </a:prstGeom>
-          <a:noFill/>
-        </p:spPr>
-        <p:txBody>
-          <a:bodyPr wrap="square" lIns="0" tIns="0" rIns="0" bIns="0">
-            <a:spAutoFit/>
-          </a:bodyPr>
-          <a:lstStyle/>
-          <a:p>
-            <a:pPr>
-              <a:spcAft>
-                <a:spcPts val="800"/>
-              </a:spcAft>
-              <a:defRPr sz="1400" b="1">
-                <a:solidFill>
-                  <a:srgbClr val="184C34"/>
-                </a:solidFill>
-              </a:defRPr>
-            </a:pPr>
-            <a:r>
-              <a:t>Kesimpulan Proyek DSS</a:t>
-            </a:r>
-          </a:p>
-          <a:p>
-            <a:pPr>
-              <a:spcAft>
-                <a:spcPts val="500"/>
-              </a:spcAft>
-              <a:defRPr sz="1150">
-                <a:solidFill>
-                  <a:srgbClr val="212529"/>
-                </a:solidFill>
-              </a:defRPr>
-            </a:pPr>
-            <a:r>
-              <a:t>• Transformasi data operasional kebun BBPP Ketindan menjadi Data Warehouse Star Schema berhasil meningkatkan kecepatan dan kedalaman analitik bisnis.</a:t>
-            </a:r>
-          </a:p>
-          <a:p>
-            <a:pPr>
-              <a:spcAft>
-                <a:spcPts val="500"/>
-              </a:spcAft>
-              <a:defRPr sz="1150">
-                <a:solidFill>
-                  <a:srgbClr val="212529"/>
-                </a:solidFill>
-              </a:defRPr>
-            </a:pPr>
-            <a:r>
-              <a:t>• 5 KPI strategis memberikan wawasan komprehensif mengenai waktu panen puncak, komoditas unggulan finansial, dan segmen pembeli kunci.</a:t>
-            </a:r>
-          </a:p>
-          <a:p>
-            <a:pPr>
-              <a:spcAft>
-                <a:spcPts val="500"/>
-              </a:spcAft>
-              <a:defRPr sz="1150">
-                <a:solidFill>
-                  <a:srgbClr val="212529"/>
-                </a:solidFill>
-              </a:defRPr>
-            </a:pPr>
-            <a:r>
-              <a:t>• Dashboard Business Intelligence terbukti efektif sebagai Decision Support System dalam memandu perencanaan masa tanam, zonasi lahan, dan kebijakan penjualan.</a:t>
-            </a:r>
-          </a:p>
-        </p:txBody>
-      </p:sp>
-      <p:sp>
-        <p:nvSpPr>
-          <p:cNvPr id="6" name="Rounded Rectangle 5"/>
+          <p:cNvPr id="5" name="Rectangle 4"/>
           <p:cNvSpPr/>
           <p:nvPr/>
         </p:nvSpPr>
         <p:spPr>
           <a:xfrm>
-            <a:off x="6309360" y="1554480"/>
-            <a:ext cx="5120640" cy="4846320"/>
-          </a:xfrm>
-          <a:prstGeom prst="roundRect">
+            <a:off x="731520" y="1554480"/>
+            <a:ext cx="73152" cy="4846320"/>
+          </a:xfrm>
+          <a:prstGeom prst="rect">
             <a:avLst/>
           </a:prstGeom>
           <a:solidFill>
-            <a:srgbClr val="FFFFFF"/>
+            <a:srgbClr val="35865B"/>
           </a:solidFill>
-          <a:ln w="19050">
-            <a:solidFill>
-              <a:srgbClr val="35865B"/>
-            </a:solidFill>
+          <a:ln>
+            <a:noFill/>
           </a:ln>
         </p:spPr>
         <p:style>
@@ -3509,14 +3424,14 @@
       </p:sp>
       <p:sp>
         <p:nvSpPr>
-          <p:cNvPr id="7" name="TextBox 6"/>
+          <p:cNvPr id="6" name="TextBox 5"/>
           <p:cNvSpPr txBox="1"/>
           <p:nvPr/>
         </p:nvSpPr>
         <p:spPr>
           <a:xfrm>
-            <a:off x="6510528" y="1719072"/>
-            <a:ext cx="4718304" cy="4517136"/>
+            <a:off x="1051560" y="1783080"/>
+            <a:ext cx="4617720" cy="4434840"/>
           </a:xfrm>
           <a:prstGeom prst="rect">
             <a:avLst/>
@@ -3531,49 +3446,226 @@
           <a:p>
             <a:pPr>
               <a:spcAft>
-                <a:spcPts val="800"/>
-              </a:spcAft>
-              <a:defRPr sz="1400" b="1">
+                <a:spcPts val="1200"/>
+              </a:spcAft>
+              <a:defRPr sz="1600" b="1">
                 <a:solidFill>
                   <a:srgbClr val="184C34"/>
                 </a:solidFill>
               </a:defRPr>
             </a:pPr>
             <a:r>
+              <a:t>Kesimpulan Proyek DSS</a:t>
+            </a:r>
+          </a:p>
+          <a:p>
+            <a:pPr>
+              <a:spcAft>
+                <a:spcPts val="1000"/>
+              </a:spcAft>
+              <a:defRPr sz="1600">
+                <a:solidFill>
+                  <a:srgbClr val="212529"/>
+                </a:solidFill>
+              </a:defRPr>
+            </a:pPr>
+            <a:r>
+              <a:t>• Transformasi data operasional kebun BBPP Ketindan menjadi Data Warehouse Star Schema berhasil meningkatkan kecepatan dan kedalaman analitik bisnis.</a:t>
+            </a:r>
+          </a:p>
+          <a:p>
+            <a:pPr>
+              <a:spcAft>
+                <a:spcPts val="1000"/>
+              </a:spcAft>
+              <a:defRPr sz="1600">
+                <a:solidFill>
+                  <a:srgbClr val="212529"/>
+                </a:solidFill>
+              </a:defRPr>
+            </a:pPr>
+            <a:r>
+              <a:t>• 5 KPI strategis memberikan wawasan komprehensif mengenai waktu panen puncak, komoditas unggulan finansial, dan segmen pembeli kunci.</a:t>
+            </a:r>
+          </a:p>
+          <a:p>
+            <a:pPr>
+              <a:spcAft>
+                <a:spcPts val="1000"/>
+              </a:spcAft>
+              <a:defRPr sz="1600">
+                <a:solidFill>
+                  <a:srgbClr val="212529"/>
+                </a:solidFill>
+              </a:defRPr>
+            </a:pPr>
+            <a:r>
+              <a:t>• Dashboard Business Intelligence terbukti efektif sebagai Decision Support System dalam memandu perencanaan masa tanam, zonasi lahan, dan kebijakan penjualan.</a:t>
+            </a:r>
+          </a:p>
+        </p:txBody>
+      </p:sp>
+      <p:sp>
+        <p:nvSpPr>
+          <p:cNvPr id="7" name="Rectangle 6"/>
+          <p:cNvSpPr/>
+          <p:nvPr/>
+        </p:nvSpPr>
+        <p:spPr>
+          <a:xfrm>
+            <a:off x="6309360" y="1554480"/>
+            <a:ext cx="5120640" cy="4846320"/>
+          </a:xfrm>
+          <a:prstGeom prst="rect">
+            <a:avLst/>
+          </a:prstGeom>
+          <a:solidFill>
+            <a:srgbClr val="F8F9FA"/>
+          </a:solidFill>
+          <a:ln w="9525">
+            <a:solidFill>
+              <a:srgbClr val="DEE2E6"/>
+            </a:solidFill>
+          </a:ln>
+        </p:spPr>
+        <p:style>
+          <a:lnRef idx="1">
+            <a:schemeClr val="accent1"/>
+          </a:lnRef>
+          <a:fillRef idx="3">
+            <a:schemeClr val="accent1"/>
+          </a:fillRef>
+          <a:effectRef idx="2">
+            <a:schemeClr val="accent1"/>
+          </a:effectRef>
+          <a:fontRef idx="minor">
+            <a:schemeClr val="lt1"/>
+          </a:fontRef>
+        </p:style>
+        <p:txBody>
+          <a:bodyPr rtlCol="0" anchor="ctr"/>
+          <a:lstStyle/>
+          <a:p>
+            <a:pPr algn="ctr"/>
+          </a:p>
+        </p:txBody>
+      </p:sp>
+      <p:sp>
+        <p:nvSpPr>
+          <p:cNvPr id="8" name="Rectangle 7"/>
+          <p:cNvSpPr/>
+          <p:nvPr/>
+        </p:nvSpPr>
+        <p:spPr>
+          <a:xfrm>
+            <a:off x="6309360" y="1554480"/>
+            <a:ext cx="73152" cy="4846320"/>
+          </a:xfrm>
+          <a:prstGeom prst="rect">
+            <a:avLst/>
+          </a:prstGeom>
+          <a:solidFill>
+            <a:srgbClr val="35865B"/>
+          </a:solidFill>
+          <a:ln>
+            <a:noFill/>
+          </a:ln>
+        </p:spPr>
+        <p:style>
+          <a:lnRef idx="1">
+            <a:schemeClr val="accent1"/>
+          </a:lnRef>
+          <a:fillRef idx="3">
+            <a:schemeClr val="accent1"/>
+          </a:fillRef>
+          <a:effectRef idx="2">
+            <a:schemeClr val="accent1"/>
+          </a:effectRef>
+          <a:fontRef idx="minor">
+            <a:schemeClr val="lt1"/>
+          </a:fontRef>
+        </p:style>
+        <p:txBody>
+          <a:bodyPr rtlCol="0" anchor="ctr"/>
+          <a:lstStyle/>
+          <a:p>
+            <a:pPr algn="ctr"/>
+          </a:p>
+        </p:txBody>
+      </p:sp>
+      <p:sp>
+        <p:nvSpPr>
+          <p:cNvPr id="9" name="TextBox 8"/>
+          <p:cNvSpPr txBox="1"/>
+          <p:nvPr/>
+        </p:nvSpPr>
+        <p:spPr>
+          <a:xfrm>
+            <a:off x="6629400" y="1783080"/>
+            <a:ext cx="4617720" cy="4434840"/>
+          </a:xfrm>
+          <a:prstGeom prst="rect">
+            <a:avLst/>
+          </a:prstGeom>
+          <a:noFill/>
+        </p:spPr>
+        <p:txBody>
+          <a:bodyPr wrap="square" lIns="0" tIns="0" rIns="0" bIns="0">
+            <a:spAutoFit/>
+          </a:bodyPr>
+          <a:lstStyle/>
+          <a:p>
+            <a:pPr>
+              <a:spcAft>
+                <a:spcPts val="1200"/>
+              </a:spcAft>
+              <a:defRPr sz="1600" b="1">
+                <a:solidFill>
+                  <a:srgbClr val="184C34"/>
+                </a:solidFill>
+              </a:defRPr>
+            </a:pPr>
+            <a:r>
               <a:t>Tautan Dashboard &amp; Berkas Pengumpulan</a:t>
             </a:r>
           </a:p>
           <a:p>
             <a:pPr>
               <a:spcAft>
-                <a:spcPts val="500"/>
-              </a:spcAft>
-              <a:defRPr sz="1150">
+                <a:spcPts val="1000"/>
+              </a:spcAft>
+              <a:defRPr sz="1600">
                 <a:solidFill>
                   <a:srgbClr val="212529"/>
                 </a:solidFill>
               </a:defRPr>
             </a:pPr>
             <a:r>
-              <a:t>• Tautan Dashboard Interaktif (Publish to Web):</a:t>
+              <a:rPr>
+                <a:hlinkClick r:id="rId2"/>
+              </a:rPr>
+              <a:t>• Tautan Dashboard Interaktif (Power BI):</a:t>
             </a:r>
             <a:br/>
             <a:r>
-              <a:t>https://app.powerbi.com/view?r=eyJrIjoiQkJQUF9LZXRpbmRhbl9EU1NfMjAyNiIsInQiOiJmYWJyaWMtY2ljZC11YiJ9</a:t>
-            </a:r>
-          </a:p>
-          <a:p>
-            <a:pPr>
-              <a:spcAft>
-                <a:spcPts val="500"/>
-              </a:spcAft>
-              <a:defRPr sz="1150">
+              <a:t>https://app.powerbi.com/links/76fma9KOTC?ctid=8b603e04-2c81-4b3c-a54e-b1211ffbceed&amp;pbi_source=linkShare</a:t>
+            </a:r>
+          </a:p>
+          <a:p>
+            <a:pPr>
+              <a:spcAft>
+                <a:spcPts val="1000"/>
+              </a:spcAft>
+              <a:defRPr sz="1600">
                 <a:solidFill>
                   <a:srgbClr val="212529"/>
                 </a:solidFill>
               </a:defRPr>
             </a:pPr>
             <a:r>
+              <a:rPr>
+                <a:hlinkClick r:id="rId3"/>
+              </a:rPr>
               <a:t>• Repositori Publik GitHub:</a:t>
             </a:r>
             <a:br/>
@@ -3584,16 +3676,16 @@
           <a:p>
             <a:pPr>
               <a:spcAft>
-                <a:spcPts val="500"/>
-              </a:spcAft>
-              <a:defRPr sz="1150">
+                <a:spcPts val="1000"/>
+              </a:spcAft>
+              <a:defRPr sz="1600">
                 <a:solidFill>
                   <a:srgbClr val="212529"/>
                 </a:solidFill>
               </a:defRPr>
             </a:pPr>
             <a:r>
-              <a:t>• Berkas Excel Star Schema (Data Bersih):</a:t>
+              <a:t>• Berkas Excel (Data Mentah, Star Schema, Ringkasan KPI):</a:t>
             </a:r>
             <a:br/>
             <a:r>
@@ -3603,9 +3695,9 @@
           <a:p>
             <a:pPr>
               <a:spcAft>
-                <a:spcPts val="500"/>
-              </a:spcAft>
-              <a:defRPr sz="1150">
+                <a:spcPts val="1000"/>
+              </a:spcAft>
+              <a:defRPr sz="1600">
                 <a:solidFill>
                   <a:srgbClr val="212529"/>
                 </a:solidFill>
@@ -3622,9 +3714,9 @@
           <a:p>
             <a:pPr>
               <a:spcAft>
-                <a:spcPts val="500"/>
-              </a:spcAft>
-              <a:defRPr sz="1150">
+                <a:spcPts val="1000"/>
+              </a:spcAft>
+              <a:defRPr sz="1600">
                 <a:solidFill>
                   <a:srgbClr val="212529"/>
                 </a:solidFill>
@@ -3748,7 +3840,7 @@
       </p:sp>
       <p:sp>
         <p:nvSpPr>
-          <p:cNvPr id="4" name="Rounded Rectangle 3"/>
+          <p:cNvPr id="4" name="Rectangle 3"/>
           <p:cNvSpPr/>
           <p:nvPr/>
         </p:nvSpPr>
@@ -3757,15 +3849,15 @@
             <a:off x="731520" y="1554480"/>
             <a:ext cx="5120640" cy="4846320"/>
           </a:xfrm>
-          <a:prstGeom prst="roundRect">
+          <a:prstGeom prst="rect">
             <a:avLst/>
           </a:prstGeom>
           <a:solidFill>
-            <a:srgbClr val="FFFFFF"/>
+            <a:srgbClr val="F8F9FA"/>
           </a:solidFill>
-          <a:ln w="19050">
+          <a:ln w="9525">
             <a:solidFill>
-              <a:srgbClr val="35865B"/>
+              <a:srgbClr val="DEE2E6"/>
             </a:solidFill>
           </a:ln>
         </p:spPr>
@@ -3793,123 +3885,23 @@
       </p:sp>
       <p:sp>
         <p:nvSpPr>
-          <p:cNvPr id="5" name="TextBox 4"/>
-          <p:cNvSpPr txBox="1"/>
-          <p:nvPr/>
-        </p:nvSpPr>
-        <p:spPr>
-          <a:xfrm>
-            <a:off x="932688" y="1719072"/>
-            <a:ext cx="4718304" cy="4517136"/>
-          </a:xfrm>
-          <a:prstGeom prst="rect">
-            <a:avLst/>
-          </a:prstGeom>
-          <a:noFill/>
-        </p:spPr>
-        <p:txBody>
-          <a:bodyPr wrap="square" lIns="0" tIns="0" rIns="0" bIns="0">
-            <a:spAutoFit/>
-          </a:bodyPr>
-          <a:lstStyle/>
-          <a:p>
-            <a:pPr>
-              <a:spcAft>
-                <a:spcPts val="800"/>
-              </a:spcAft>
-              <a:defRPr sz="1400" b="1">
-                <a:solidFill>
-                  <a:srgbClr val="184C34"/>
-                </a:solidFill>
-              </a:defRPr>
-            </a:pPr>
-            <a:r>
-              <a:t>Profil Balai &amp; Unit Kebun Produksi</a:t>
-            </a:r>
-          </a:p>
-          <a:p>
-            <a:pPr>
-              <a:spcAft>
-                <a:spcPts val="500"/>
-              </a:spcAft>
-              <a:defRPr sz="1150">
-                <a:solidFill>
-                  <a:srgbClr val="212529"/>
-                </a:solidFill>
-              </a:defRPr>
-            </a:pPr>
-            <a:r>
-              <a:t>• Balai Besar Pelatihan Pertanian (BBPP) Ketindan (Lawang, Malang) adalah UPT di bawah BPPSDMP, Kementerian Pertanian RI.</a:t>
-            </a:r>
-          </a:p>
-          <a:p>
-            <a:pPr>
-              <a:spcAft>
-                <a:spcPts val="500"/>
-              </a:spcAft>
-              <a:defRPr sz="1150">
-                <a:solidFill>
-                  <a:srgbClr val="212529"/>
-                </a:solidFill>
-              </a:defRPr>
-            </a:pPr>
-            <a:r>
-              <a:t>• Menjalankan fungsi pelatihan vokasi aparatur pertanian sekaligus mengelola kebun produksi komersial (Smart Greenhouse &amp; Lahan Terbuka).</a:t>
-            </a:r>
-          </a:p>
-          <a:p>
-            <a:pPr>
-              <a:spcAft>
-                <a:spcPts val="500"/>
-              </a:spcAft>
-              <a:defRPr sz="1150">
-                <a:solidFill>
-                  <a:srgbClr val="212529"/>
-                </a:solidFill>
-              </a:defRPr>
-            </a:pPr>
-            <a:r>
-              <a:t>• Menghasilkan komoditas hortikultura unggulan: Melon Eksklusif (Sweet Lavender, Sweet Hammy, The Blues), Tomat Cherry, Pete, dan Sayuran Hidroponik.</a:t>
-            </a:r>
-          </a:p>
-          <a:p>
-            <a:pPr>
-              <a:spcAft>
-                <a:spcPts val="500"/>
-              </a:spcAft>
-              <a:defRPr sz="1150">
-                <a:solidFill>
-                  <a:srgbClr val="212529"/>
-                </a:solidFill>
-              </a:defRPr>
-            </a:pPr>
-            <a:r>
-              <a:t>• Hasil panen didistribusikan ke pasar grosir borongan kota besar (Surabaya, Batu), rekanan vendor, koperasi, dan pembeli langsung.</a:t>
-            </a:r>
-          </a:p>
-        </p:txBody>
-      </p:sp>
-      <p:sp>
-        <p:nvSpPr>
-          <p:cNvPr id="6" name="Rounded Rectangle 5"/>
+          <p:cNvPr id="5" name="Rectangle 4"/>
           <p:cNvSpPr/>
           <p:nvPr/>
         </p:nvSpPr>
         <p:spPr>
           <a:xfrm>
-            <a:off x="6309360" y="1554480"/>
-            <a:ext cx="5120640" cy="4846320"/>
-          </a:xfrm>
-          <a:prstGeom prst="roundRect">
+            <a:off x="731520" y="1554480"/>
+            <a:ext cx="73152" cy="4846320"/>
+          </a:xfrm>
+          <a:prstGeom prst="rect">
             <a:avLst/>
           </a:prstGeom>
           <a:solidFill>
-            <a:srgbClr val="FFFFFF"/>
+            <a:srgbClr val="35865B"/>
           </a:solidFill>
-          <a:ln w="19050">
-            <a:solidFill>
-              <a:srgbClr val="35865B"/>
-            </a:solidFill>
+          <a:ln>
+            <a:noFill/>
           </a:ln>
         </p:spPr>
         <p:style>
@@ -3936,14 +3928,14 @@
       </p:sp>
       <p:sp>
         <p:nvSpPr>
-          <p:cNvPr id="7" name="TextBox 6"/>
+          <p:cNvPr id="6" name="TextBox 5"/>
           <p:cNvSpPr txBox="1"/>
           <p:nvPr/>
         </p:nvSpPr>
         <p:spPr>
           <a:xfrm>
-            <a:off x="6510528" y="1719072"/>
-            <a:ext cx="4718304" cy="4517136"/>
+            <a:off x="1051560" y="1783080"/>
+            <a:ext cx="4617720" cy="4434840"/>
           </a:xfrm>
           <a:prstGeom prst="rect">
             <a:avLst/>
@@ -3958,24 +3950,210 @@
           <a:p>
             <a:pPr>
               <a:spcAft>
-                <a:spcPts val="800"/>
-              </a:spcAft>
-              <a:defRPr sz="1400" b="1">
+                <a:spcPts val="1200"/>
+              </a:spcAft>
+              <a:defRPr sz="1600" b="1">
                 <a:solidFill>
                   <a:srgbClr val="184C34"/>
                 </a:solidFill>
               </a:defRPr>
             </a:pPr>
             <a:r>
+              <a:t>Profil Balai &amp; Unit Kebun Produksi</a:t>
+            </a:r>
+          </a:p>
+          <a:p>
+            <a:pPr>
+              <a:spcAft>
+                <a:spcPts val="1000"/>
+              </a:spcAft>
+              <a:defRPr sz="1600">
+                <a:solidFill>
+                  <a:srgbClr val="212529"/>
+                </a:solidFill>
+              </a:defRPr>
+            </a:pPr>
+            <a:r>
+              <a:t>• Balai Besar Pelatihan Pertanian (BBPP) Ketindan (Lawang, Malang) adalah UPT di bawah BPPSDMP, Kementerian Pertanian RI.</a:t>
+            </a:r>
+          </a:p>
+          <a:p>
+            <a:pPr>
+              <a:spcAft>
+                <a:spcPts val="1000"/>
+              </a:spcAft>
+              <a:defRPr sz="1600">
+                <a:solidFill>
+                  <a:srgbClr val="212529"/>
+                </a:solidFill>
+              </a:defRPr>
+            </a:pPr>
+            <a:r>
+              <a:t>• Menjalankan fungsi pelatihan vokasi aparatur pertanian sekaligus mengelola kebun produksi komersial (Smart Greenhouse &amp; Lahan Terbuka).</a:t>
+            </a:r>
+          </a:p>
+          <a:p>
+            <a:pPr>
+              <a:spcAft>
+                <a:spcPts val="1000"/>
+              </a:spcAft>
+              <a:defRPr sz="1600">
+                <a:solidFill>
+                  <a:srgbClr val="212529"/>
+                </a:solidFill>
+              </a:defRPr>
+            </a:pPr>
+            <a:r>
+              <a:t>• Menghasilkan komoditas hortikultura unggulan: Melon Eksklusif (Sweet Lavender, Sweet Hammy, The Blues), Tomat Cherry, Pete, dan Sayuran Hidroponik.</a:t>
+            </a:r>
+          </a:p>
+          <a:p>
+            <a:pPr>
+              <a:spcAft>
+                <a:spcPts val="1000"/>
+              </a:spcAft>
+              <a:defRPr sz="1600">
+                <a:solidFill>
+                  <a:srgbClr val="212529"/>
+                </a:solidFill>
+              </a:defRPr>
+            </a:pPr>
+            <a:r>
+              <a:t>• Hasil panen didistribusikan ke pasar grosir borongan kota besar (Surabaya, Batu), rekanan vendor, koperasi, dan pembeli langsung.</a:t>
+            </a:r>
+          </a:p>
+        </p:txBody>
+      </p:sp>
+      <p:sp>
+        <p:nvSpPr>
+          <p:cNvPr id="7" name="Rectangle 6"/>
+          <p:cNvSpPr/>
+          <p:nvPr/>
+        </p:nvSpPr>
+        <p:spPr>
+          <a:xfrm>
+            <a:off x="6309360" y="1554480"/>
+            <a:ext cx="5120640" cy="4846320"/>
+          </a:xfrm>
+          <a:prstGeom prst="rect">
+            <a:avLst/>
+          </a:prstGeom>
+          <a:solidFill>
+            <a:srgbClr val="F8F9FA"/>
+          </a:solidFill>
+          <a:ln w="9525">
+            <a:solidFill>
+              <a:srgbClr val="DEE2E6"/>
+            </a:solidFill>
+          </a:ln>
+        </p:spPr>
+        <p:style>
+          <a:lnRef idx="1">
+            <a:schemeClr val="accent1"/>
+          </a:lnRef>
+          <a:fillRef idx="3">
+            <a:schemeClr val="accent1"/>
+          </a:fillRef>
+          <a:effectRef idx="2">
+            <a:schemeClr val="accent1"/>
+          </a:effectRef>
+          <a:fontRef idx="minor">
+            <a:schemeClr val="lt1"/>
+          </a:fontRef>
+        </p:style>
+        <p:txBody>
+          <a:bodyPr rtlCol="0" anchor="ctr"/>
+          <a:lstStyle/>
+          <a:p>
+            <a:pPr algn="ctr"/>
+          </a:p>
+        </p:txBody>
+      </p:sp>
+      <p:sp>
+        <p:nvSpPr>
+          <p:cNvPr id="8" name="Rectangle 7"/>
+          <p:cNvSpPr/>
+          <p:nvPr/>
+        </p:nvSpPr>
+        <p:spPr>
+          <a:xfrm>
+            <a:off x="6309360" y="1554480"/>
+            <a:ext cx="73152" cy="4846320"/>
+          </a:xfrm>
+          <a:prstGeom prst="rect">
+            <a:avLst/>
+          </a:prstGeom>
+          <a:solidFill>
+            <a:srgbClr val="35865B"/>
+          </a:solidFill>
+          <a:ln>
+            <a:noFill/>
+          </a:ln>
+        </p:spPr>
+        <p:style>
+          <a:lnRef idx="1">
+            <a:schemeClr val="accent1"/>
+          </a:lnRef>
+          <a:fillRef idx="3">
+            <a:schemeClr val="accent1"/>
+          </a:fillRef>
+          <a:effectRef idx="2">
+            <a:schemeClr val="accent1"/>
+          </a:effectRef>
+          <a:fontRef idx="minor">
+            <a:schemeClr val="lt1"/>
+          </a:fontRef>
+        </p:style>
+        <p:txBody>
+          <a:bodyPr rtlCol="0" anchor="ctr"/>
+          <a:lstStyle/>
+          <a:p>
+            <a:pPr algn="ctr"/>
+          </a:p>
+        </p:txBody>
+      </p:sp>
+      <p:sp>
+        <p:nvSpPr>
+          <p:cNvPr id="9" name="TextBox 8"/>
+          <p:cNvSpPr txBox="1"/>
+          <p:nvPr/>
+        </p:nvSpPr>
+        <p:spPr>
+          <a:xfrm>
+            <a:off x="6629400" y="1783080"/>
+            <a:ext cx="4617720" cy="4434840"/>
+          </a:xfrm>
+          <a:prstGeom prst="rect">
+            <a:avLst/>
+          </a:prstGeom>
+          <a:noFill/>
+        </p:spPr>
+        <p:txBody>
+          <a:bodyPr wrap="square" lIns="0" tIns="0" rIns="0" bIns="0">
+            <a:spAutoFit/>
+          </a:bodyPr>
+          <a:lstStyle/>
+          <a:p>
+            <a:pPr>
+              <a:spcAft>
+                <a:spcPts val="1200"/>
+              </a:spcAft>
+              <a:defRPr sz="1600" b="1">
+                <a:solidFill>
+                  <a:srgbClr val="184C34"/>
+                </a:solidFill>
+              </a:defRPr>
+            </a:pPr>
+            <a:r>
               <a:t>Tantangan Bisnis &amp; Kebutuhan DSS</a:t>
             </a:r>
           </a:p>
           <a:p>
             <a:pPr>
               <a:spcAft>
-                <a:spcPts val="500"/>
-              </a:spcAft>
-              <a:defRPr sz="1150">
+                <a:spcPts val="1000"/>
+              </a:spcAft>
+              <a:defRPr sz="1600">
                 <a:solidFill>
                   <a:srgbClr val="212529"/>
                 </a:solidFill>
@@ -3988,9 +4166,9 @@
           <a:p>
             <a:pPr>
               <a:spcAft>
-                <a:spcPts val="500"/>
-              </a:spcAft>
-              <a:defRPr sz="1150">
+                <a:spcPts val="1000"/>
+              </a:spcAft>
+              <a:defRPr sz="1600">
                 <a:solidFill>
                   <a:srgbClr val="212529"/>
                 </a:solidFill>
@@ -4003,9 +4181,9 @@
           <a:p>
             <a:pPr>
               <a:spcAft>
-                <a:spcPts val="500"/>
-              </a:spcAft>
-              <a:defRPr sz="1150">
+                <a:spcPts val="1000"/>
+              </a:spcAft>
+              <a:defRPr sz="1600">
                 <a:solidFill>
                   <a:srgbClr val="212529"/>
                 </a:solidFill>
@@ -4018,9 +4196,9 @@
           <a:p>
             <a:pPr>
               <a:spcAft>
-                <a:spcPts val="500"/>
-              </a:spcAft>
-              <a:defRPr sz="1150">
+                <a:spcPts val="1000"/>
+              </a:spcAft>
+              <a:defRPr sz="1600">
                 <a:solidFill>
                   <a:srgbClr val="212529"/>
                 </a:solidFill>
@@ -4144,7 +4322,7 @@
       </p:sp>
       <p:sp>
         <p:nvSpPr>
-          <p:cNvPr id="4" name="Rounded Rectangle 3"/>
+          <p:cNvPr id="4" name="Rectangle 3"/>
           <p:cNvSpPr/>
           <p:nvPr/>
         </p:nvSpPr>
@@ -4153,15 +4331,15 @@
             <a:off x="731520" y="1554480"/>
             <a:ext cx="3383280" cy="4846320"/>
           </a:xfrm>
-          <a:prstGeom prst="roundRect">
+          <a:prstGeom prst="rect">
             <a:avLst/>
           </a:prstGeom>
           <a:solidFill>
-            <a:srgbClr val="FFFFFF"/>
+            <a:srgbClr val="F8F9FA"/>
           </a:solidFill>
-          <a:ln w="19050">
+          <a:ln w="9525">
             <a:solidFill>
-              <a:srgbClr val="35865B"/>
+              <a:srgbClr val="DEE2E6"/>
             </a:solidFill>
           </a:ln>
         </p:spPr>
@@ -4189,101 +4367,23 @@
       </p:sp>
       <p:sp>
         <p:nvSpPr>
-          <p:cNvPr id="5" name="TextBox 4"/>
-          <p:cNvSpPr txBox="1"/>
-          <p:nvPr/>
-        </p:nvSpPr>
-        <p:spPr>
-          <a:xfrm>
-            <a:off x="932688" y="1719072"/>
-            <a:ext cx="2980944" cy="4517136"/>
-          </a:xfrm>
-          <a:prstGeom prst="rect">
-            <a:avLst/>
-          </a:prstGeom>
-          <a:noFill/>
-        </p:spPr>
-        <p:txBody>
-          <a:bodyPr wrap="square" lIns="0" tIns="0" rIns="0" bIns="0">
-            <a:spAutoFit/>
-          </a:bodyPr>
-          <a:lstStyle/>
-          <a:p>
-            <a:pPr>
-              <a:spcAft>
-                <a:spcPts val="800"/>
-              </a:spcAft>
-              <a:defRPr sz="1400" b="1">
-                <a:solidFill>
-                  <a:srgbClr val="184C34"/>
-                </a:solidFill>
-              </a:defRPr>
-            </a:pPr>
-            <a:r>
-              <a:t>KPI Dimensi Waktu</a:t>
-            </a:r>
-          </a:p>
-          <a:p>
-            <a:pPr>
-              <a:spcAft>
-                <a:spcPts val="500"/>
-              </a:spcAft>
-              <a:defRPr sz="1150">
-                <a:solidFill>
-                  <a:srgbClr val="212529"/>
-                </a:solidFill>
-              </a:defRPr>
-            </a:pPr>
-            <a:r>
-              <a:t>• KPI 1: Pendapatan Penjualan Mingguan</a:t>
-            </a:r>
-            <a:br/>
-            <a:r>
-              <a:t>Memantau likuiditas kas operasional harian/mingguan dan mendeteksi minggu puncak panen (harvest surge) secara tepat.</a:t>
-            </a:r>
-          </a:p>
-          <a:p>
-            <a:pPr>
-              <a:spcAft>
-                <a:spcPts val="500"/>
-              </a:spcAft>
-              <a:defRPr sz="1150">
-                <a:solidFill>
-                  <a:srgbClr val="212529"/>
-                </a:solidFill>
-              </a:defRPr>
-            </a:pPr>
-            <a:r>
-              <a:t>• KPI 2: Pendapatan Penjualan Bulanan</a:t>
-            </a:r>
-            <a:br/>
-            <a:r>
-              <a:t>Evaluasi pencapaian target berkala (Agustus vs September 2026) dan mengukur pertumbuhan MoM (+81,4%).</a:t>
-            </a:r>
-          </a:p>
-        </p:txBody>
-      </p:sp>
-      <p:sp>
-        <p:nvSpPr>
-          <p:cNvPr id="6" name="Rounded Rectangle 5"/>
+          <p:cNvPr id="5" name="Rectangle 4"/>
           <p:cNvSpPr/>
           <p:nvPr/>
         </p:nvSpPr>
         <p:spPr>
           <a:xfrm>
-            <a:off x="4389120" y="1554480"/>
-            <a:ext cx="3383280" cy="4846320"/>
-          </a:xfrm>
-          <a:prstGeom prst="roundRect">
+            <a:off x="731520" y="1554480"/>
+            <a:ext cx="73152" cy="4846320"/>
+          </a:xfrm>
+          <a:prstGeom prst="rect">
             <a:avLst/>
           </a:prstGeom>
           <a:solidFill>
-            <a:srgbClr val="FFFFFF"/>
+            <a:srgbClr val="35865B"/>
           </a:solidFill>
-          <a:ln w="19050">
-            <a:solidFill>
-              <a:srgbClr val="35865B"/>
-            </a:solidFill>
+          <a:ln>
+            <a:noFill/>
           </a:ln>
         </p:spPr>
         <p:style>
@@ -4310,14 +4410,14 @@
       </p:sp>
       <p:sp>
         <p:nvSpPr>
-          <p:cNvPr id="7" name="TextBox 6"/>
+          <p:cNvPr id="6" name="TextBox 5"/>
           <p:cNvSpPr txBox="1"/>
           <p:nvPr/>
         </p:nvSpPr>
         <p:spPr>
           <a:xfrm>
-            <a:off x="4590288" y="1719072"/>
-            <a:ext cx="2980944" cy="4517136"/>
+            <a:off x="1051560" y="1783080"/>
+            <a:ext cx="2880360" cy="4434840"/>
           </a:xfrm>
           <a:prstGeom prst="rect">
             <a:avLst/>
@@ -4332,78 +4432,78 @@
           <a:p>
             <a:pPr>
               <a:spcAft>
-                <a:spcPts val="800"/>
-              </a:spcAft>
-              <a:defRPr sz="1400" b="1">
+                <a:spcPts val="1200"/>
+              </a:spcAft>
+              <a:defRPr sz="1600" b="1">
                 <a:solidFill>
                   <a:srgbClr val="184C34"/>
                 </a:solidFill>
               </a:defRPr>
             </a:pPr>
             <a:r>
-              <a:t>KPI Portofolio Produk</a:t>
-            </a:r>
-          </a:p>
-          <a:p>
-            <a:pPr>
-              <a:spcAft>
-                <a:spcPts val="500"/>
-              </a:spcAft>
-              <a:defRPr sz="1150">
+              <a:t>KPI Dimensi Waktu</a:t>
+            </a:r>
+          </a:p>
+          <a:p>
+            <a:pPr>
+              <a:spcAft>
+                <a:spcPts val="1000"/>
+              </a:spcAft>
+              <a:defRPr sz="1600">
                 <a:solidFill>
                   <a:srgbClr val="212529"/>
                 </a:solidFill>
               </a:defRPr>
             </a:pPr>
             <a:r>
-              <a:t>• KPI 3: Produk Pendapatan Terbesar</a:t>
+              <a:t>• KPI 1: Pendapatan Penjualan Mingguan</a:t>
             </a:r>
             <a:br/>
             <a:r>
-              <a:t>Menentukan komoditas tulang punggung finansial (Melon Sweet Lavender Rp 14,44 Jt &amp; Tomat Cherry Rp 9,60 Jt).</a:t>
-            </a:r>
-          </a:p>
-          <a:p>
-            <a:pPr>
-              <a:spcAft>
-                <a:spcPts val="500"/>
-              </a:spcAft>
-              <a:defRPr sz="1150">
+              <a:t>Memantau likuiditas kas operasional harian/mingguan dan mendeteksi minggu puncak panen (harvest surge) secara tepat.</a:t>
+            </a:r>
+          </a:p>
+          <a:p>
+            <a:pPr>
+              <a:spcAft>
+                <a:spcPts val="1000"/>
+              </a:spcAft>
+              <a:defRPr sz="1600">
                 <a:solidFill>
                   <a:srgbClr val="212529"/>
                 </a:solidFill>
               </a:defRPr>
             </a:pPr>
             <a:r>
-              <a:t>• KPI 4: Produk Terbanyak Terjual (Volume)</a:t>
+              <a:t>• KPI 2: Pendapatan Penjualan Bulanan</a:t>
             </a:r>
             <a:br/>
             <a:r>
-              <a:t>Menilai serapan kuantitas pasar (Melon 860 buah, Pete 487 ikat) guna mitigasi risiko pembusukan panen.</a:t>
-            </a:r>
-          </a:p>
-        </p:txBody>
-      </p:sp>
-      <p:sp>
-        <p:nvSpPr>
-          <p:cNvPr id="8" name="Rounded Rectangle 7"/>
+              <a:t>Evaluasi pencapaian target berkala (Agustus vs September 2026) dan mengukur pertumbuhan MoM (+81,4%).</a:t>
+            </a:r>
+          </a:p>
+        </p:txBody>
+      </p:sp>
+      <p:sp>
+        <p:nvSpPr>
+          <p:cNvPr id="7" name="Rectangle 6"/>
           <p:cNvSpPr/>
           <p:nvPr/>
         </p:nvSpPr>
         <p:spPr>
           <a:xfrm>
-            <a:off x="8046720" y="1554480"/>
+            <a:off x="4389120" y="1554480"/>
             <a:ext cx="3383280" cy="4846320"/>
           </a:xfrm>
-          <a:prstGeom prst="roundRect">
+          <a:prstGeom prst="rect">
             <a:avLst/>
           </a:prstGeom>
           <a:solidFill>
-            <a:srgbClr val="FFFFFF"/>
+            <a:srgbClr val="F8F9FA"/>
           </a:solidFill>
-          <a:ln w="19050">
+          <a:ln w="9525">
             <a:solidFill>
-              <a:srgbClr val="35865B"/>
+              <a:srgbClr val="DEE2E6"/>
             </a:solidFill>
           </a:ln>
         </p:spPr>
@@ -4431,14 +4531,57 @@
       </p:sp>
       <p:sp>
         <p:nvSpPr>
+          <p:cNvPr id="8" name="Rectangle 7"/>
+          <p:cNvSpPr/>
+          <p:nvPr/>
+        </p:nvSpPr>
+        <p:spPr>
+          <a:xfrm>
+            <a:off x="4389120" y="1554480"/>
+            <a:ext cx="73152" cy="4846320"/>
+          </a:xfrm>
+          <a:prstGeom prst="rect">
+            <a:avLst/>
+          </a:prstGeom>
+          <a:solidFill>
+            <a:srgbClr val="35865B"/>
+          </a:solidFill>
+          <a:ln>
+            <a:noFill/>
+          </a:ln>
+        </p:spPr>
+        <p:style>
+          <a:lnRef idx="1">
+            <a:schemeClr val="accent1"/>
+          </a:lnRef>
+          <a:fillRef idx="3">
+            <a:schemeClr val="accent1"/>
+          </a:fillRef>
+          <a:effectRef idx="2">
+            <a:schemeClr val="accent1"/>
+          </a:effectRef>
+          <a:fontRef idx="minor">
+            <a:schemeClr val="lt1"/>
+          </a:fontRef>
+        </p:style>
+        <p:txBody>
+          <a:bodyPr rtlCol="0" anchor="ctr"/>
+          <a:lstStyle/>
+          <a:p>
+            <a:pPr algn="ctr"/>
+          </a:p>
+        </p:txBody>
+      </p:sp>
+      <p:sp>
+        <p:nvSpPr>
           <p:cNvPr id="9" name="TextBox 8"/>
           <p:cNvSpPr txBox="1"/>
           <p:nvPr/>
         </p:nvSpPr>
         <p:spPr>
           <a:xfrm>
-            <a:off x="8247888" y="1719072"/>
-            <a:ext cx="2980944" cy="4517136"/>
+            <a:off x="4709160" y="1783080"/>
+            <a:ext cx="2880360" cy="4434840"/>
           </a:xfrm>
           <a:prstGeom prst="rect">
             <a:avLst/>
@@ -4453,24 +4596,188 @@
           <a:p>
             <a:pPr>
               <a:spcAft>
-                <a:spcPts val="800"/>
-              </a:spcAft>
-              <a:defRPr sz="1400" b="1">
+                <a:spcPts val="1200"/>
+              </a:spcAft>
+              <a:defRPr sz="1600" b="1">
                 <a:solidFill>
                   <a:srgbClr val="184C34"/>
                 </a:solidFill>
               </a:defRPr>
             </a:pPr>
             <a:r>
+              <a:t>KPI Portofolio Produk</a:t>
+            </a:r>
+          </a:p>
+          <a:p>
+            <a:pPr>
+              <a:spcAft>
+                <a:spcPts val="1000"/>
+              </a:spcAft>
+              <a:defRPr sz="1600">
+                <a:solidFill>
+                  <a:srgbClr val="212529"/>
+                </a:solidFill>
+              </a:defRPr>
+            </a:pPr>
+            <a:r>
+              <a:t>• KPI 3: Produk Pendapatan Terbesar</a:t>
+            </a:r>
+            <a:br/>
+            <a:r>
+              <a:t>Menentukan komoditas tulang punggung finansial (Melon Sweet Lavender Rp 14,44 Jt &amp; Tomat Cherry Rp 9,60 Jt).</a:t>
+            </a:r>
+          </a:p>
+          <a:p>
+            <a:pPr>
+              <a:spcAft>
+                <a:spcPts val="1000"/>
+              </a:spcAft>
+              <a:defRPr sz="1600">
+                <a:solidFill>
+                  <a:srgbClr val="212529"/>
+                </a:solidFill>
+              </a:defRPr>
+            </a:pPr>
+            <a:r>
+              <a:t>• KPI 4: Produk Terbanyak Terjual (Volume)</a:t>
+            </a:r>
+            <a:br/>
+            <a:r>
+              <a:t>Menilai serapan kuantitas pasar (Melon Sweet Lavender 860 kg, Pete 487 pack) guna mitigasi risiko pembusukan panen.</a:t>
+            </a:r>
+          </a:p>
+        </p:txBody>
+      </p:sp>
+      <p:sp>
+        <p:nvSpPr>
+          <p:cNvPr id="10" name="Rectangle 9"/>
+          <p:cNvSpPr/>
+          <p:nvPr/>
+        </p:nvSpPr>
+        <p:spPr>
+          <a:xfrm>
+            <a:off x="8046720" y="1554480"/>
+            <a:ext cx="3383280" cy="4846320"/>
+          </a:xfrm>
+          <a:prstGeom prst="rect">
+            <a:avLst/>
+          </a:prstGeom>
+          <a:solidFill>
+            <a:srgbClr val="F8F9FA"/>
+          </a:solidFill>
+          <a:ln w="9525">
+            <a:solidFill>
+              <a:srgbClr val="DEE2E6"/>
+            </a:solidFill>
+          </a:ln>
+        </p:spPr>
+        <p:style>
+          <a:lnRef idx="1">
+            <a:schemeClr val="accent1"/>
+          </a:lnRef>
+          <a:fillRef idx="3">
+            <a:schemeClr val="accent1"/>
+          </a:fillRef>
+          <a:effectRef idx="2">
+            <a:schemeClr val="accent1"/>
+          </a:effectRef>
+          <a:fontRef idx="minor">
+            <a:schemeClr val="lt1"/>
+          </a:fontRef>
+        </p:style>
+        <p:txBody>
+          <a:bodyPr rtlCol="0" anchor="ctr"/>
+          <a:lstStyle/>
+          <a:p>
+            <a:pPr algn="ctr"/>
+          </a:p>
+        </p:txBody>
+      </p:sp>
+      <p:sp>
+        <p:nvSpPr>
+          <p:cNvPr id="11" name="Rectangle 10"/>
+          <p:cNvSpPr/>
+          <p:nvPr/>
+        </p:nvSpPr>
+        <p:spPr>
+          <a:xfrm>
+            <a:off x="8046720" y="1554480"/>
+            <a:ext cx="73152" cy="4846320"/>
+          </a:xfrm>
+          <a:prstGeom prst="rect">
+            <a:avLst/>
+          </a:prstGeom>
+          <a:solidFill>
+            <a:srgbClr val="35865B"/>
+          </a:solidFill>
+          <a:ln>
+            <a:noFill/>
+          </a:ln>
+        </p:spPr>
+        <p:style>
+          <a:lnRef idx="1">
+            <a:schemeClr val="accent1"/>
+          </a:lnRef>
+          <a:fillRef idx="3">
+            <a:schemeClr val="accent1"/>
+          </a:fillRef>
+          <a:effectRef idx="2">
+            <a:schemeClr val="accent1"/>
+          </a:effectRef>
+          <a:fontRef idx="minor">
+            <a:schemeClr val="lt1"/>
+          </a:fontRef>
+        </p:style>
+        <p:txBody>
+          <a:bodyPr rtlCol="0" anchor="ctr"/>
+          <a:lstStyle/>
+          <a:p>
+            <a:pPr algn="ctr"/>
+          </a:p>
+        </p:txBody>
+      </p:sp>
+      <p:sp>
+        <p:nvSpPr>
+          <p:cNvPr id="12" name="TextBox 11"/>
+          <p:cNvSpPr txBox="1"/>
+          <p:nvPr/>
+        </p:nvSpPr>
+        <p:spPr>
+          <a:xfrm>
+            <a:off x="8366760" y="1783080"/>
+            <a:ext cx="2880360" cy="4434840"/>
+          </a:xfrm>
+          <a:prstGeom prst="rect">
+            <a:avLst/>
+          </a:prstGeom>
+          <a:noFill/>
+        </p:spPr>
+        <p:txBody>
+          <a:bodyPr wrap="square" lIns="0" tIns="0" rIns="0" bIns="0">
+            <a:spAutoFit/>
+          </a:bodyPr>
+          <a:lstStyle/>
+          <a:p>
+            <a:pPr>
+              <a:spcAft>
+                <a:spcPts val="1200"/>
+              </a:spcAft>
+              <a:defRPr sz="1600" b="1">
+                <a:solidFill>
+                  <a:srgbClr val="184C34"/>
+                </a:solidFill>
+              </a:defRPr>
+            </a:pPr>
+            <a:r>
               <a:t>KPI Hubungan Pelanggan</a:t>
             </a:r>
           </a:p>
           <a:p>
             <a:pPr>
               <a:spcAft>
-                <a:spcPts val="500"/>
-              </a:spcAft>
-              <a:defRPr sz="1150">
+                <a:spcPts val="1000"/>
+              </a:spcAft>
+              <a:defRPr sz="1600">
                 <a:solidFill>
                   <a:srgbClr val="212529"/>
                 </a:solidFill>
@@ -4487,9 +4794,9 @@
           <a:p>
             <a:pPr>
               <a:spcAft>
-                <a:spcPts val="500"/>
-              </a:spcAft>
-              <a:defRPr sz="1150">
+                <a:spcPts val="1000"/>
+              </a:spcAft>
+              <a:defRPr sz="1600">
                 <a:solidFill>
                   <a:srgbClr val="212529"/>
                 </a:solidFill>
@@ -4617,7 +4924,7 @@
       </p:sp>
       <p:sp>
         <p:nvSpPr>
-          <p:cNvPr id="4" name="Rounded Rectangle 3"/>
+          <p:cNvPr id="4" name="Rectangle 3"/>
           <p:cNvSpPr/>
           <p:nvPr/>
         </p:nvSpPr>
@@ -4626,15 +4933,15 @@
             <a:off x="731520" y="1554480"/>
             <a:ext cx="5120640" cy="4846320"/>
           </a:xfrm>
-          <a:prstGeom prst="roundRect">
+          <a:prstGeom prst="rect">
             <a:avLst/>
           </a:prstGeom>
           <a:solidFill>
-            <a:srgbClr val="FFFFFF"/>
+            <a:srgbClr val="F8F9FA"/>
           </a:solidFill>
-          <a:ln w="19050">
+          <a:ln w="9525">
             <a:solidFill>
-              <a:srgbClr val="35865B"/>
+              <a:srgbClr val="DEE2E6"/>
             </a:solidFill>
           </a:ln>
         </p:spPr>
@@ -4662,138 +4969,23 @@
       </p:sp>
       <p:sp>
         <p:nvSpPr>
-          <p:cNvPr id="5" name="TextBox 4"/>
-          <p:cNvSpPr txBox="1"/>
-          <p:nvPr/>
-        </p:nvSpPr>
-        <p:spPr>
-          <a:xfrm>
-            <a:off x="932688" y="1719072"/>
-            <a:ext cx="4718304" cy="4517136"/>
-          </a:xfrm>
-          <a:prstGeom prst="rect">
-            <a:avLst/>
-          </a:prstGeom>
-          <a:noFill/>
-        </p:spPr>
-        <p:txBody>
-          <a:bodyPr wrap="square" lIns="0" tIns="0" rIns="0" bIns="0">
-            <a:spAutoFit/>
-          </a:bodyPr>
-          <a:lstStyle/>
-          <a:p>
-            <a:pPr>
-              <a:spcAft>
-                <a:spcPts val="800"/>
-              </a:spcAft>
-              <a:defRPr sz="1400" b="1">
-                <a:solidFill>
-                  <a:srgbClr val="184C34"/>
-                </a:solidFill>
-              </a:defRPr>
-            </a:pPr>
-            <a:r>
-              <a:t>Karakteristik Data Aktual Transaksi</a:t>
-            </a:r>
-          </a:p>
-          <a:p>
-            <a:pPr>
-              <a:spcAft>
-                <a:spcPts val="500"/>
-              </a:spcAft>
-              <a:defRPr sz="1150">
-                <a:solidFill>
-                  <a:srgbClr val="212529"/>
-                </a:solidFill>
-              </a:defRPr>
-            </a:pPr>
-            <a:r>
-              <a:t>• Sumber data: Buku kasir harian kebun produksi periode 3 Agustus 2026 s.d. 25 September 2026.</a:t>
-            </a:r>
-          </a:p>
-          <a:p>
-            <a:pPr>
-              <a:spcAft>
-                <a:spcPts val="500"/>
-              </a:spcAft>
-              <a:defRPr sz="1150">
-                <a:solidFill>
-                  <a:srgbClr val="212529"/>
-                </a:solidFill>
-              </a:defRPr>
-            </a:pPr>
-            <a:r>
-              <a:t>• Periode waktu: 8 minggu operasional penuh (melampaui syarat minimal 3 minggu pada pedoman tugas).</a:t>
-            </a:r>
-          </a:p>
-          <a:p>
-            <a:pPr>
-              <a:spcAft>
-                <a:spcPts val="500"/>
-              </a:spcAft>
-              <a:defRPr sz="1150">
-                <a:solidFill>
-                  <a:srgbClr val="212529"/>
-                </a:solidFill>
-              </a:defRPr>
-            </a:pPr>
-            <a:r>
-              <a:t>• Total transaksi: 549 baris pencatatan transaksi valid.</a:t>
-            </a:r>
-          </a:p>
-          <a:p>
-            <a:pPr>
-              <a:spcAft>
-                <a:spcPts val="500"/>
-              </a:spcAft>
-              <a:defRPr sz="1150">
-                <a:solidFill>
-                  <a:srgbClr val="212529"/>
-                </a:solidFill>
-              </a:defRPr>
-            </a:pPr>
-            <a:r>
-              <a:t>• Total omzet riil terverifikasi: Rp 29.818.920.</a:t>
-            </a:r>
-          </a:p>
-          <a:p>
-            <a:pPr>
-              <a:spcAft>
-                <a:spcPts val="500"/>
-              </a:spcAft>
-              <a:defRPr sz="1150">
-                <a:solidFill>
-                  <a:srgbClr val="212529"/>
-                </a:solidFill>
-              </a:defRPr>
-            </a:pPr>
-            <a:r>
-              <a:t>• Cakupan entitas: 16 komoditas unik, 9 grade mutu, 214 pembeli unik, dan 5 blok lahan pertanian.</a:t>
-            </a:r>
-          </a:p>
-        </p:txBody>
-      </p:sp>
-      <p:sp>
-        <p:nvSpPr>
-          <p:cNvPr id="6" name="Rounded Rectangle 5"/>
+          <p:cNvPr id="5" name="Rectangle 4"/>
           <p:cNvSpPr/>
           <p:nvPr/>
         </p:nvSpPr>
         <p:spPr>
           <a:xfrm>
-            <a:off x="6309360" y="1554480"/>
-            <a:ext cx="5120640" cy="4846320"/>
-          </a:xfrm>
-          <a:prstGeom prst="roundRect">
+            <a:off x="731520" y="1554480"/>
+            <a:ext cx="73152" cy="4846320"/>
+          </a:xfrm>
+          <a:prstGeom prst="rect">
             <a:avLst/>
           </a:prstGeom>
           <a:solidFill>
-            <a:srgbClr val="FFFFFF"/>
+            <a:srgbClr val="35865B"/>
           </a:solidFill>
-          <a:ln w="19050">
-            <a:solidFill>
-              <a:srgbClr val="35865B"/>
-            </a:solidFill>
+          <a:ln>
+            <a:noFill/>
           </a:ln>
         </p:spPr>
         <p:style>
@@ -4820,14 +5012,14 @@
       </p:sp>
       <p:sp>
         <p:nvSpPr>
-          <p:cNvPr id="7" name="TextBox 6"/>
+          <p:cNvPr id="6" name="TextBox 5"/>
           <p:cNvSpPr txBox="1"/>
           <p:nvPr/>
         </p:nvSpPr>
         <p:spPr>
           <a:xfrm>
-            <a:off x="6510528" y="1719072"/>
-            <a:ext cx="4718304" cy="4517136"/>
+            <a:off x="1051560" y="1783080"/>
+            <a:ext cx="4617720" cy="4434840"/>
           </a:xfrm>
           <a:prstGeom prst="rect">
             <a:avLst/>
@@ -4842,39 +5034,240 @@
           <a:p>
             <a:pPr>
               <a:spcAft>
-                <a:spcPts val="800"/>
-              </a:spcAft>
-              <a:defRPr sz="1400" b="1">
+                <a:spcPts val="1200"/>
+              </a:spcAft>
+              <a:defRPr sz="1600" b="1">
                 <a:solidFill>
                   <a:srgbClr val="184C34"/>
                 </a:solidFill>
               </a:defRPr>
             </a:pPr>
             <a:r>
+              <a:t>Karakteristik Data Aktual Transaksi</a:t>
+            </a:r>
+          </a:p>
+          <a:p>
+            <a:pPr>
+              <a:spcAft>
+                <a:spcPts val="1000"/>
+              </a:spcAft>
+              <a:defRPr sz="1600">
+                <a:solidFill>
+                  <a:srgbClr val="212529"/>
+                </a:solidFill>
+              </a:defRPr>
+            </a:pPr>
+            <a:r>
+              <a:t>• Sumber data: Buku kasir harian kebun produksi periode 3 Agustus 2026 s.d. 25 September 2026.</a:t>
+            </a:r>
+          </a:p>
+          <a:p>
+            <a:pPr>
+              <a:spcAft>
+                <a:spcPts val="1000"/>
+              </a:spcAft>
+              <a:defRPr sz="1600">
+                <a:solidFill>
+                  <a:srgbClr val="212529"/>
+                </a:solidFill>
+              </a:defRPr>
+            </a:pPr>
+            <a:r>
+              <a:t>• Periode waktu: 8 minggu operasional penuh (melampaui syarat minimal 3 minggu pada pedoman tugas).</a:t>
+            </a:r>
+          </a:p>
+          <a:p>
+            <a:pPr>
+              <a:spcAft>
+                <a:spcPts val="1000"/>
+              </a:spcAft>
+              <a:defRPr sz="1600">
+                <a:solidFill>
+                  <a:srgbClr val="212529"/>
+                </a:solidFill>
+              </a:defRPr>
+            </a:pPr>
+            <a:r>
+              <a:t>• Total transaksi: 549 baris pencatatan transaksi valid.</a:t>
+            </a:r>
+          </a:p>
+          <a:p>
+            <a:pPr>
+              <a:spcAft>
+                <a:spcPts val="1000"/>
+              </a:spcAft>
+              <a:defRPr sz="1600">
+                <a:solidFill>
+                  <a:srgbClr val="212529"/>
+                </a:solidFill>
+              </a:defRPr>
+            </a:pPr>
+            <a:r>
+              <a:t>• Total omzet riil terverifikasi: Rp 29.818.920.</a:t>
+            </a:r>
+          </a:p>
+          <a:p>
+            <a:pPr>
+              <a:spcAft>
+                <a:spcPts val="1000"/>
+              </a:spcAft>
+              <a:defRPr sz="1600">
+                <a:solidFill>
+                  <a:srgbClr val="212529"/>
+                </a:solidFill>
+              </a:defRPr>
+            </a:pPr>
+            <a:r>
+              <a:t>• Cakupan entitas: 16 komoditas unik, 9 label grade mutu, 214 pembeli unik, dan 5 blok lahan pertanian.</a:t>
+            </a:r>
+          </a:p>
+        </p:txBody>
+      </p:sp>
+      <p:sp>
+        <p:nvSpPr>
+          <p:cNvPr id="7" name="Rectangle 6"/>
+          <p:cNvSpPr/>
+          <p:nvPr/>
+        </p:nvSpPr>
+        <p:spPr>
+          <a:xfrm>
+            <a:off x="6309360" y="1554480"/>
+            <a:ext cx="5120640" cy="4846320"/>
+          </a:xfrm>
+          <a:prstGeom prst="rect">
+            <a:avLst/>
+          </a:prstGeom>
+          <a:solidFill>
+            <a:srgbClr val="F8F9FA"/>
+          </a:solidFill>
+          <a:ln w="9525">
+            <a:solidFill>
+              <a:srgbClr val="DEE2E6"/>
+            </a:solidFill>
+          </a:ln>
+        </p:spPr>
+        <p:style>
+          <a:lnRef idx="1">
+            <a:schemeClr val="accent1"/>
+          </a:lnRef>
+          <a:fillRef idx="3">
+            <a:schemeClr val="accent1"/>
+          </a:fillRef>
+          <a:effectRef idx="2">
+            <a:schemeClr val="accent1"/>
+          </a:effectRef>
+          <a:fontRef idx="minor">
+            <a:schemeClr val="lt1"/>
+          </a:fontRef>
+        </p:style>
+        <p:txBody>
+          <a:bodyPr rtlCol="0" anchor="ctr"/>
+          <a:lstStyle/>
+          <a:p>
+            <a:pPr algn="ctr"/>
+          </a:p>
+        </p:txBody>
+      </p:sp>
+      <p:sp>
+        <p:nvSpPr>
+          <p:cNvPr id="8" name="Rectangle 7"/>
+          <p:cNvSpPr/>
+          <p:nvPr/>
+        </p:nvSpPr>
+        <p:spPr>
+          <a:xfrm>
+            <a:off x="6309360" y="1554480"/>
+            <a:ext cx="73152" cy="4846320"/>
+          </a:xfrm>
+          <a:prstGeom prst="rect">
+            <a:avLst/>
+          </a:prstGeom>
+          <a:solidFill>
+            <a:srgbClr val="35865B"/>
+          </a:solidFill>
+          <a:ln>
+            <a:noFill/>
+          </a:ln>
+        </p:spPr>
+        <p:style>
+          <a:lnRef idx="1">
+            <a:schemeClr val="accent1"/>
+          </a:lnRef>
+          <a:fillRef idx="3">
+            <a:schemeClr val="accent1"/>
+          </a:fillRef>
+          <a:effectRef idx="2">
+            <a:schemeClr val="accent1"/>
+          </a:effectRef>
+          <a:fontRef idx="minor">
+            <a:schemeClr val="lt1"/>
+          </a:fontRef>
+        </p:style>
+        <p:txBody>
+          <a:bodyPr rtlCol="0" anchor="ctr"/>
+          <a:lstStyle/>
+          <a:p>
+            <a:pPr algn="ctr"/>
+          </a:p>
+        </p:txBody>
+      </p:sp>
+      <p:sp>
+        <p:nvSpPr>
+          <p:cNvPr id="9" name="TextBox 8"/>
+          <p:cNvSpPr txBox="1"/>
+          <p:nvPr/>
+        </p:nvSpPr>
+        <p:spPr>
+          <a:xfrm>
+            <a:off x="6629400" y="1783080"/>
+            <a:ext cx="4617720" cy="4434840"/>
+          </a:xfrm>
+          <a:prstGeom prst="rect">
+            <a:avLst/>
+          </a:prstGeom>
+          <a:noFill/>
+        </p:spPr>
+        <p:txBody>
+          <a:bodyPr wrap="square" lIns="0" tIns="0" rIns="0" bIns="0">
+            <a:spAutoFit/>
+          </a:bodyPr>
+          <a:lstStyle/>
+          <a:p>
+            <a:pPr>
+              <a:spcAft>
+                <a:spcPts val="1200"/>
+              </a:spcAft>
+              <a:defRPr sz="1600" b="1">
+                <a:solidFill>
+                  <a:srgbClr val="184C34"/>
+                </a:solidFill>
+              </a:defRPr>
+            </a:pPr>
+            <a:r>
               <a:t>Tahapan Data Cleansing &amp; Transformasi</a:t>
             </a:r>
           </a:p>
           <a:p>
             <a:pPr>
               <a:spcAft>
-                <a:spcPts val="500"/>
-              </a:spcAft>
-              <a:defRPr sz="1150">
+                <a:spcPts val="1000"/>
+              </a:spcAft>
+              <a:defRPr sz="1600">
                 <a:solidFill>
                   <a:srgbClr val="212529"/>
                 </a:solidFill>
               </a:defRPr>
             </a:pPr>
             <a:r>
-              <a:t>• Koreksi Anomali Tanggal: Ditemukan 8 baris transaksi tertulis tahun 2025, 2028, dan 2029 (human error saat input); dinormalisasi ke tahun 2026 berdasarkan runtutan nomor transaksi.</a:t>
-            </a:r>
-          </a:p>
-          <a:p>
-            <a:pPr>
-              <a:spcAft>
-                <a:spcPts val="500"/>
-              </a:spcAft>
-              <a:defRPr sz="1150">
+              <a:t>• Koreksi Anomali Tanggal: Ditemukan 7 baris bertahun salah (4 baris 2025, 2 baris 2028, 1 baris 2029) dan 2 tanggal berformat teks; dinormalisasi ke 2026 berdasarkan runtutan nomor transaksi.</a:t>
+            </a:r>
+          </a:p>
+          <a:p>
+            <a:pPr>
+              <a:spcAft>
+                <a:spcPts val="1000"/>
+              </a:spcAft>
+              <a:defRPr sz="1600">
                 <a:solidFill>
                   <a:srgbClr val="212529"/>
                 </a:solidFill>
@@ -4887,24 +5280,24 @@
           <a:p>
             <a:pPr>
               <a:spcAft>
-                <a:spcPts val="500"/>
-              </a:spcAft>
-              <a:defRPr sz="1150">
+                <a:spcPts val="1000"/>
+              </a:spcAft>
+              <a:defRPr sz="1600">
                 <a:solidFill>
                   <a:srgbClr val="212529"/>
                 </a:solidFill>
               </a:defRPr>
             </a:pPr>
             <a:r>
-              <a:t>• Harmonisasi Satuan &amp; Grade: Menyeragamkan format satuan ('Kg', 'Pack', 'Ikat', 'Buah') dan grade ('A', 'B', 'C', 'Non Grade').</a:t>
-            </a:r>
-          </a:p>
-          <a:p>
-            <a:pPr>
-              <a:spcAft>
-                <a:spcPts val="500"/>
-              </a:spcAft>
-              <a:defRPr sz="1150">
+              <a:t>• Harmonisasi Satuan: Menyeragamkan penulisan satuan ('kg' menjadi 'Kg', 'paket' menjadi 'Pack' dengan harga identik) sehingga tersisa 4 satuan: Kg, Pack, Ikat, Buah.</a:t>
+            </a:r>
+          </a:p>
+          <a:p>
+            <a:pPr>
+              <a:spcAft>
+                <a:spcPts val="1000"/>
+              </a:spcAft>
+              <a:defRPr sz="1600">
                 <a:solidFill>
                   <a:srgbClr val="212529"/>
                 </a:solidFill>
@@ -5052,7 +5445,7 @@
       </p:pic>
       <p:sp>
         <p:nvSpPr>
-          <p:cNvPr id="5" name="Rounded Rectangle 4"/>
+          <p:cNvPr id="5" name="Rectangle 4"/>
           <p:cNvSpPr/>
           <p:nvPr/>
         </p:nvSpPr>
@@ -5061,15 +5454,15 @@
             <a:off x="7132320" y="1554480"/>
             <a:ext cx="4327855" cy="4846320"/>
           </a:xfrm>
-          <a:prstGeom prst="roundRect">
+          <a:prstGeom prst="rect">
             <a:avLst/>
           </a:prstGeom>
           <a:solidFill>
-            <a:srgbClr val="FFFFFF"/>
+            <a:srgbClr val="F8F9FA"/>
           </a:solidFill>
-          <a:ln w="19050">
+          <a:ln w="9525">
             <a:solidFill>
-              <a:srgbClr val="35865B"/>
+              <a:srgbClr val="DEE2E6"/>
             </a:solidFill>
           </a:ln>
         </p:spPr>
@@ -5097,14 +5490,57 @@
       </p:sp>
       <p:sp>
         <p:nvSpPr>
-          <p:cNvPr id="6" name="TextBox 5"/>
+          <p:cNvPr id="6" name="Rectangle 5"/>
+          <p:cNvSpPr/>
+          <p:nvPr/>
+        </p:nvSpPr>
+        <p:spPr>
+          <a:xfrm>
+            <a:off x="7132320" y="1554480"/>
+            <a:ext cx="73152" cy="4846320"/>
+          </a:xfrm>
+          <a:prstGeom prst="rect">
+            <a:avLst/>
+          </a:prstGeom>
+          <a:solidFill>
+            <a:srgbClr val="35865B"/>
+          </a:solidFill>
+          <a:ln>
+            <a:noFill/>
+          </a:ln>
+        </p:spPr>
+        <p:style>
+          <a:lnRef idx="1">
+            <a:schemeClr val="accent1"/>
+          </a:lnRef>
+          <a:fillRef idx="3">
+            <a:schemeClr val="accent1"/>
+          </a:fillRef>
+          <a:effectRef idx="2">
+            <a:schemeClr val="accent1"/>
+          </a:effectRef>
+          <a:fontRef idx="minor">
+            <a:schemeClr val="lt1"/>
+          </a:fontRef>
+        </p:style>
+        <p:txBody>
+          <a:bodyPr rtlCol="0" anchor="ctr"/>
+          <a:lstStyle/>
+          <a:p>
+            <a:pPr algn="ctr"/>
+          </a:p>
+        </p:txBody>
+      </p:sp>
+      <p:sp>
+        <p:nvSpPr>
+          <p:cNvPr id="7" name="TextBox 6"/>
           <p:cNvSpPr txBox="1"/>
           <p:nvPr/>
         </p:nvSpPr>
         <p:spPr>
           <a:xfrm>
-            <a:off x="7333488" y="1719072"/>
-            <a:ext cx="3925519" cy="4517136"/>
+            <a:off x="7452360" y="1783080"/>
+            <a:ext cx="3824935" cy="4434840"/>
           </a:xfrm>
           <a:prstGeom prst="rect">
             <a:avLst/>
@@ -5119,9 +5555,9 @@
           <a:p>
             <a:pPr>
               <a:spcAft>
-                <a:spcPts val="800"/>
-              </a:spcAft>
-              <a:defRPr sz="1400" b="1">
+                <a:spcPts val="1200"/>
+              </a:spcAft>
+              <a:defRPr sz="1600" b="1">
                 <a:solidFill>
                   <a:srgbClr val="184C34"/>
                 </a:solidFill>
@@ -5134,9 +5570,9 @@
           <a:p>
             <a:pPr>
               <a:spcAft>
-                <a:spcPts val="500"/>
-              </a:spcAft>
-              <a:defRPr sz="1150">
+                <a:spcPts val="1000"/>
+              </a:spcAft>
+              <a:defRPr sz="1300">
                 <a:solidFill>
                   <a:srgbClr val="212529"/>
                 </a:solidFill>
@@ -5153,9 +5589,9 @@
           <a:p>
             <a:pPr>
               <a:spcAft>
-                <a:spcPts val="500"/>
-              </a:spcAft>
-              <a:defRPr sz="1150">
+                <a:spcPts val="1000"/>
+              </a:spcAft>
+              <a:defRPr sz="1300">
                 <a:solidFill>
                   <a:srgbClr val="212529"/>
                 </a:solidFill>
@@ -5172,9 +5608,9 @@
           <a:p>
             <a:pPr>
               <a:spcAft>
-                <a:spcPts val="500"/>
-              </a:spcAft>
-              <a:defRPr sz="1150">
+                <a:spcPts val="1000"/>
+              </a:spcAft>
+              <a:defRPr sz="1300">
                 <a:solidFill>
                   <a:srgbClr val="212529"/>
                 </a:solidFill>
@@ -5191,9 +5627,9 @@
           <a:p>
             <a:pPr>
               <a:spcAft>
-                <a:spcPts val="500"/>
-              </a:spcAft>
-              <a:defRPr sz="1150">
+                <a:spcPts val="1000"/>
+              </a:spcAft>
+              <a:defRPr sz="1300">
                 <a:solidFill>
                   <a:srgbClr val="212529"/>
                 </a:solidFill>
@@ -5210,9 +5646,9 @@
           <a:p>
             <a:pPr>
               <a:spcAft>
-                <a:spcPts val="500"/>
-              </a:spcAft>
-              <a:defRPr sz="1150">
+                <a:spcPts val="1000"/>
+              </a:spcAft>
+              <a:defRPr sz="1300">
                 <a:solidFill>
                   <a:srgbClr val="212529"/>
                 </a:solidFill>
@@ -5229,9 +5665,9 @@
           <a:p>
             <a:pPr>
               <a:spcAft>
-                <a:spcPts val="500"/>
-              </a:spcAft>
-              <a:defRPr sz="1150">
+                <a:spcPts val="1000"/>
+              </a:spcAft>
+              <a:defRPr sz="1300">
                 <a:solidFill>
                   <a:srgbClr val="212529"/>
                 </a:solidFill>
@@ -5383,7 +5819,7 @@
       </p:pic>
       <p:sp>
         <p:nvSpPr>
-          <p:cNvPr id="5" name="Rounded Rectangle 4"/>
+          <p:cNvPr id="5" name="Rectangle 4"/>
           <p:cNvSpPr/>
           <p:nvPr/>
         </p:nvSpPr>
@@ -5392,15 +5828,15 @@
             <a:off x="7498079" y="1554480"/>
             <a:ext cx="3962095" cy="4846320"/>
           </a:xfrm>
-          <a:prstGeom prst="roundRect">
+          <a:prstGeom prst="rect">
             <a:avLst/>
           </a:prstGeom>
           <a:solidFill>
-            <a:srgbClr val="FFFFFF"/>
+            <a:srgbClr val="F8F9FA"/>
           </a:solidFill>
-          <a:ln w="19050">
+          <a:ln w="9525">
             <a:solidFill>
-              <a:srgbClr val="35865B"/>
+              <a:srgbClr val="DEE2E6"/>
             </a:solidFill>
           </a:ln>
         </p:spPr>
@@ -5428,14 +5864,57 @@
       </p:sp>
       <p:sp>
         <p:nvSpPr>
-          <p:cNvPr id="6" name="TextBox 5"/>
+          <p:cNvPr id="6" name="Rectangle 5"/>
+          <p:cNvSpPr/>
+          <p:nvPr/>
+        </p:nvSpPr>
+        <p:spPr>
+          <a:xfrm>
+            <a:off x="7498079" y="1554480"/>
+            <a:ext cx="73152" cy="4846320"/>
+          </a:xfrm>
+          <a:prstGeom prst="rect">
+            <a:avLst/>
+          </a:prstGeom>
+          <a:solidFill>
+            <a:srgbClr val="35865B"/>
+          </a:solidFill>
+          <a:ln>
+            <a:noFill/>
+          </a:ln>
+        </p:spPr>
+        <p:style>
+          <a:lnRef idx="1">
+            <a:schemeClr val="accent1"/>
+          </a:lnRef>
+          <a:fillRef idx="3">
+            <a:schemeClr val="accent1"/>
+          </a:fillRef>
+          <a:effectRef idx="2">
+            <a:schemeClr val="accent1"/>
+          </a:effectRef>
+          <a:fontRef idx="minor">
+            <a:schemeClr val="lt1"/>
+          </a:fontRef>
+        </p:style>
+        <p:txBody>
+          <a:bodyPr rtlCol="0" anchor="ctr"/>
+          <a:lstStyle/>
+          <a:p>
+            <a:pPr algn="ctr"/>
+          </a:p>
+        </p:txBody>
+      </p:sp>
+      <p:sp>
+        <p:nvSpPr>
+          <p:cNvPr id="7" name="TextBox 6"/>
           <p:cNvSpPr txBox="1"/>
           <p:nvPr/>
         </p:nvSpPr>
         <p:spPr>
           <a:xfrm>
-            <a:off x="7699247" y="1719072"/>
-            <a:ext cx="3559759" cy="4517136"/>
+            <a:off x="7818119" y="1783080"/>
+            <a:ext cx="3459175" cy="4434840"/>
           </a:xfrm>
           <a:prstGeom prst="rect">
             <a:avLst/>
@@ -5450,9 +5929,9 @@
           <a:p>
             <a:pPr>
               <a:spcAft>
-                <a:spcPts val="800"/>
-              </a:spcAft>
-              <a:defRPr sz="1400" b="1">
+                <a:spcPts val="1200"/>
+              </a:spcAft>
+              <a:defRPr sz="1600" b="1">
                 <a:solidFill>
                   <a:srgbClr val="184C34"/>
                 </a:solidFill>
@@ -5465,9 +5944,9 @@
           <a:p>
             <a:pPr>
               <a:spcAft>
-                <a:spcPts val="500"/>
-              </a:spcAft>
-              <a:defRPr sz="1150">
+                <a:spcPts val="1000"/>
+              </a:spcAft>
+              <a:defRPr sz="1300">
                 <a:solidFill>
                   <a:srgbClr val="212529"/>
                 </a:solidFill>
@@ -5480,16 +5959,16 @@
           <a:p>
             <a:pPr>
               <a:spcAft>
-                <a:spcPts val="500"/>
-              </a:spcAft>
-              <a:defRPr sz="1150">
+                <a:spcPts val="1000"/>
+              </a:spcAft>
+              <a:defRPr sz="1300">
                 <a:solidFill>
                   <a:srgbClr val="212529"/>
                 </a:solidFill>
               </a:defRPr>
             </a:pPr>
             <a:r>
-              <a:t>• 5 Executive Cards (Atas):</a:t>
+              <a:t>• 3 KPI Cards (Atas):</a:t>
             </a:r>
             <a:br/>
             <a:r>
@@ -5497,57 +5976,49 @@
             </a:r>
             <a:br/>
             <a:r>
-              <a:t>• Volume: 2.378 Unit/Kg</a:t>
+              <a:t>• Total Volume: 2.116 (gabungan Kg/Pack/Ikat/Buah)</a:t>
             </a:r>
             <a:br/>
             <a:r>
-              <a:t>• Transaksi: 549 Transaksi</a:t>
+              <a:t>• Total Transaksi: 549 transaksi</a:t>
+            </a:r>
+          </a:p>
+          <a:p>
+            <a:pPr>
+              <a:spcAft>
+                <a:spcPts val="1000"/>
+              </a:spcAft>
+              <a:defRPr sz="1300">
+                <a:solidFill>
+                  <a:srgbClr val="212529"/>
+                </a:solidFill>
+              </a:defRPr>
+            </a:pPr>
+            <a:r>
+              <a:t>• Prinsip F-Shape Reading:</a:t>
             </a:r>
             <a:br/>
             <a:r>
-              <a:t>• Pembeli Unik: 214 Pembeli</a:t>
+              <a:t>KPI terpenting berada di posisi pandangan pertama (kiri atas) agar pimpinan dapat mengevaluasi kesehatan finansial dalam 5 detik.</a:t>
+            </a:r>
+          </a:p>
+          <a:p>
+            <a:pPr>
+              <a:spcAft>
+                <a:spcPts val="1000"/>
+              </a:spcAft>
+              <a:defRPr sz="1300">
+                <a:solidFill>
+                  <a:srgbClr val="212529"/>
+                </a:solidFill>
+              </a:defRPr>
+            </a:pPr>
+            <a:r>
+              <a:t>• Interaktivitas:</a:t>
             </a:r>
             <a:br/>
             <a:r>
-              <a:t>• Produk Teratas: Melon Lavender</a:t>
-            </a:r>
-          </a:p>
-          <a:p>
-            <a:pPr>
-              <a:spcAft>
-                <a:spcPts val="500"/>
-              </a:spcAft>
-              <a:defRPr sz="1150">
-                <a:solidFill>
-                  <a:srgbClr val="212529"/>
-                </a:solidFill>
-              </a:defRPr>
-            </a:pPr>
-            <a:r>
-              <a:t>• Prinsip F-Shape Reading:</a:t>
-            </a:r>
-            <a:br/>
-            <a:r>
-              <a:t>KPI terpenting berada di posisi pandangan pertama (kiri atas) agar pimpinan dapat mengevaluasi kesehatan finansial dalam 5 detik.</a:t>
-            </a:r>
-          </a:p>
-          <a:p>
-            <a:pPr>
-              <a:spcAft>
-                <a:spcPts val="500"/>
-              </a:spcAft>
-              <a:defRPr sz="1150">
-                <a:solidFill>
-                  <a:srgbClr val="212529"/>
-                </a:solidFill>
-              </a:defRPr>
-            </a:pPr>
-            <a:r>
-              <a:t>• Slicer Interaktif:</a:t>
-            </a:r>
-            <a:br/>
-            <a:r>
-              <a:t>Filter dinamis berdasarkan Bulan, Blok Lahan, dan Komoditas.</a:t>
+              <a:t>Slicer Bulan (Agustus/September) dan cross-filter: klik batang, irisan donut lahan, atau baris pembeli untuk memfilter seluruh visual.</a:t>
             </a:r>
           </a:p>
         </p:txBody>
@@ -5664,7 +6135,7 @@
       </p:sp>
       <p:sp>
         <p:nvSpPr>
-          <p:cNvPr id="4" name="Rounded Rectangle 3"/>
+          <p:cNvPr id="4" name="Rectangle 3"/>
           <p:cNvSpPr/>
           <p:nvPr/>
         </p:nvSpPr>
@@ -5673,15 +6144,15 @@
             <a:off x="731520" y="1554480"/>
             <a:ext cx="5120640" cy="4846320"/>
           </a:xfrm>
-          <a:prstGeom prst="roundRect">
+          <a:prstGeom prst="rect">
             <a:avLst/>
           </a:prstGeom>
           <a:solidFill>
-            <a:srgbClr val="FFFFFF"/>
+            <a:srgbClr val="F8F9FA"/>
           </a:solidFill>
-          <a:ln w="19050">
+          <a:ln w="9525">
             <a:solidFill>
-              <a:srgbClr val="35865B"/>
+              <a:srgbClr val="DEE2E6"/>
             </a:solidFill>
           </a:ln>
         </p:spPr>
@@ -5709,116 +6180,23 @@
       </p:sp>
       <p:sp>
         <p:nvSpPr>
-          <p:cNvPr id="5" name="TextBox 4"/>
-          <p:cNvSpPr txBox="1"/>
-          <p:nvPr/>
-        </p:nvSpPr>
-        <p:spPr>
-          <a:xfrm>
-            <a:off x="932688" y="1719072"/>
-            <a:ext cx="4718304" cy="4517136"/>
-          </a:xfrm>
-          <a:prstGeom prst="rect">
-            <a:avLst/>
-          </a:prstGeom>
-          <a:noFill/>
-        </p:spPr>
-        <p:txBody>
-          <a:bodyPr wrap="square" lIns="0" tIns="0" rIns="0" bIns="0">
-            <a:spAutoFit/>
-          </a:bodyPr>
-          <a:lstStyle/>
-          <a:p>
-            <a:pPr>
-              <a:spcAft>
-                <a:spcPts val="800"/>
-              </a:spcAft>
-              <a:defRPr sz="1400" b="1">
-                <a:solidFill>
-                  <a:srgbClr val="184C34"/>
-                </a:solidFill>
-              </a:defRPr>
-            </a:pPr>
-            <a:r>
-              <a:t>Dinamika Tren Waktu (KPI 1 &amp; KPI 2)</a:t>
-            </a:r>
-          </a:p>
-          <a:p>
-            <a:pPr>
-              <a:spcAft>
-                <a:spcPts val="500"/>
-              </a:spcAft>
-              <a:defRPr sz="1150">
-                <a:solidFill>
-                  <a:srgbClr val="212529"/>
-                </a:solidFill>
-              </a:defRPr>
-            </a:pPr>
-            <a:r>
-              <a:t>• Lonjakan Minggu ke-36 (KPI 1):</a:t>
-            </a:r>
-            <a:br/>
-            <a:r>
-              <a:t>Pendapatan mencapai puncak di Minggu ke-36 sebesar Rp 15.121.720 (menyumbang 50,7% dari total omzet 2 bulan) akibat panen raya Melon Lavender.</a:t>
-            </a:r>
-          </a:p>
-          <a:p>
-            <a:pPr>
-              <a:spcAft>
-                <a:spcPts val="500"/>
-              </a:spcAft>
-              <a:defRPr sz="1150">
-                <a:solidFill>
-                  <a:srgbClr val="212529"/>
-                </a:solidFill>
-              </a:defRPr>
-            </a:pPr>
-            <a:r>
-              <a:t>• Pertumbuhan Bulanan MoM (KPI 2):</a:t>
-            </a:r>
-            <a:br/>
-            <a:r>
-              <a:t>Bulan September mencatat Rp 19,22 Jt dibanding Agustus Rp 10,60 Jt, tumbuh signifikan sebesar +81,4%.</a:t>
-            </a:r>
-          </a:p>
-          <a:p>
-            <a:pPr>
-              <a:spcAft>
-                <a:spcPts val="500"/>
-              </a:spcAft>
-              <a:defRPr sz="1150">
-                <a:solidFill>
-                  <a:srgbClr val="212529"/>
-                </a:solidFill>
-              </a:defRPr>
-            </a:pPr>
-            <a:r>
-              <a:t>• Implikasi DSS: Menunjukkan adanya seasonal spike tinggi yang membutuhkan persiapan logistik dan saluran penjualan borongan.</a:t>
-            </a:r>
-          </a:p>
-        </p:txBody>
-      </p:sp>
-      <p:sp>
-        <p:nvSpPr>
-          <p:cNvPr id="6" name="Rounded Rectangle 5"/>
+          <p:cNvPr id="5" name="Rectangle 4"/>
           <p:cNvSpPr/>
           <p:nvPr/>
         </p:nvSpPr>
         <p:spPr>
           <a:xfrm>
-            <a:off x="6309360" y="1554480"/>
-            <a:ext cx="5120640" cy="4846320"/>
-          </a:xfrm>
-          <a:prstGeom prst="roundRect">
+            <a:off x="731520" y="1554480"/>
+            <a:ext cx="73152" cy="4846320"/>
+          </a:xfrm>
+          <a:prstGeom prst="rect">
             <a:avLst/>
           </a:prstGeom>
           <a:solidFill>
-            <a:srgbClr val="FFFFFF"/>
+            <a:srgbClr val="35865B"/>
           </a:solidFill>
-          <a:ln w="19050">
-            <a:solidFill>
-              <a:srgbClr val="35865B"/>
-            </a:solidFill>
+          <a:ln>
+            <a:noFill/>
           </a:ln>
         </p:spPr>
         <p:style>
@@ -5845,14 +6223,14 @@
       </p:sp>
       <p:sp>
         <p:nvSpPr>
-          <p:cNvPr id="7" name="TextBox 6"/>
+          <p:cNvPr id="6" name="TextBox 5"/>
           <p:cNvSpPr txBox="1"/>
           <p:nvPr/>
         </p:nvSpPr>
         <p:spPr>
           <a:xfrm>
-            <a:off x="6510528" y="1719072"/>
-            <a:ext cx="4718304" cy="4517136"/>
+            <a:off x="1051560" y="1783080"/>
+            <a:ext cx="4617720" cy="4434840"/>
           </a:xfrm>
           <a:prstGeom prst="rect">
             <a:avLst/>
@@ -5867,24 +6245,203 @@
           <a:p>
             <a:pPr>
               <a:spcAft>
-                <a:spcPts val="800"/>
-              </a:spcAft>
-              <a:defRPr sz="1400" b="1">
+                <a:spcPts val="1200"/>
+              </a:spcAft>
+              <a:defRPr sz="1600" b="1">
                 <a:solidFill>
                   <a:srgbClr val="184C34"/>
                 </a:solidFill>
               </a:defRPr>
             </a:pPr>
             <a:r>
+              <a:t>Dinamika Tren Waktu (KPI 1 &amp; KPI 2)</a:t>
+            </a:r>
+          </a:p>
+          <a:p>
+            <a:pPr>
+              <a:spcAft>
+                <a:spcPts val="1000"/>
+              </a:spcAft>
+              <a:defRPr sz="1600">
+                <a:solidFill>
+                  <a:srgbClr val="212529"/>
+                </a:solidFill>
+              </a:defRPr>
+            </a:pPr>
+            <a:r>
+              <a:t>• Lonjakan Minggu ke-36 (KPI 1):</a:t>
+            </a:r>
+            <a:br/>
+            <a:r>
+              <a:t>Pendapatan mencapai puncak di Minggu ke-36 sebesar Rp 15.121.720 (menyumbang 50,7% dari total omzet 2 bulan) akibat panen raya Melon Lavender.</a:t>
+            </a:r>
+          </a:p>
+          <a:p>
+            <a:pPr>
+              <a:spcAft>
+                <a:spcPts val="1000"/>
+              </a:spcAft>
+              <a:defRPr sz="1600">
+                <a:solidFill>
+                  <a:srgbClr val="212529"/>
+                </a:solidFill>
+              </a:defRPr>
+            </a:pPr>
+            <a:r>
+              <a:t>• Pertumbuhan Bulanan MoM (KPI 2):</a:t>
+            </a:r>
+            <a:br/>
+            <a:r>
+              <a:t>Bulan September mencatat Rp 19,22 Jt dibanding Agustus Rp 10,60 Jt, tumbuh signifikan sebesar +81,4%.</a:t>
+            </a:r>
+          </a:p>
+          <a:p>
+            <a:pPr>
+              <a:spcAft>
+                <a:spcPts val="1000"/>
+              </a:spcAft>
+              <a:defRPr sz="1600">
+                <a:solidFill>
+                  <a:srgbClr val="212529"/>
+                </a:solidFill>
+              </a:defRPr>
+            </a:pPr>
+            <a:r>
+              <a:t>• Implikasi DSS: Menunjukkan adanya seasonal spike tinggi yang membutuhkan persiapan logistik dan saluran penjualan borongan.</a:t>
+            </a:r>
+          </a:p>
+        </p:txBody>
+      </p:sp>
+      <p:sp>
+        <p:nvSpPr>
+          <p:cNvPr id="7" name="Rectangle 6"/>
+          <p:cNvSpPr/>
+          <p:nvPr/>
+        </p:nvSpPr>
+        <p:spPr>
+          <a:xfrm>
+            <a:off x="6309360" y="1554480"/>
+            <a:ext cx="5120640" cy="4846320"/>
+          </a:xfrm>
+          <a:prstGeom prst="rect">
+            <a:avLst/>
+          </a:prstGeom>
+          <a:solidFill>
+            <a:srgbClr val="F8F9FA"/>
+          </a:solidFill>
+          <a:ln w="9525">
+            <a:solidFill>
+              <a:srgbClr val="DEE2E6"/>
+            </a:solidFill>
+          </a:ln>
+        </p:spPr>
+        <p:style>
+          <a:lnRef idx="1">
+            <a:schemeClr val="accent1"/>
+          </a:lnRef>
+          <a:fillRef idx="3">
+            <a:schemeClr val="accent1"/>
+          </a:fillRef>
+          <a:effectRef idx="2">
+            <a:schemeClr val="accent1"/>
+          </a:effectRef>
+          <a:fontRef idx="minor">
+            <a:schemeClr val="lt1"/>
+          </a:fontRef>
+        </p:style>
+        <p:txBody>
+          <a:bodyPr rtlCol="0" anchor="ctr"/>
+          <a:lstStyle/>
+          <a:p>
+            <a:pPr algn="ctr"/>
+          </a:p>
+        </p:txBody>
+      </p:sp>
+      <p:sp>
+        <p:nvSpPr>
+          <p:cNvPr id="8" name="Rectangle 7"/>
+          <p:cNvSpPr/>
+          <p:nvPr/>
+        </p:nvSpPr>
+        <p:spPr>
+          <a:xfrm>
+            <a:off x="6309360" y="1554480"/>
+            <a:ext cx="73152" cy="4846320"/>
+          </a:xfrm>
+          <a:prstGeom prst="rect">
+            <a:avLst/>
+          </a:prstGeom>
+          <a:solidFill>
+            <a:srgbClr val="35865B"/>
+          </a:solidFill>
+          <a:ln>
+            <a:noFill/>
+          </a:ln>
+        </p:spPr>
+        <p:style>
+          <a:lnRef idx="1">
+            <a:schemeClr val="accent1"/>
+          </a:lnRef>
+          <a:fillRef idx="3">
+            <a:schemeClr val="accent1"/>
+          </a:fillRef>
+          <a:effectRef idx="2">
+            <a:schemeClr val="accent1"/>
+          </a:effectRef>
+          <a:fontRef idx="minor">
+            <a:schemeClr val="lt1"/>
+          </a:fontRef>
+        </p:style>
+        <p:txBody>
+          <a:bodyPr rtlCol="0" anchor="ctr"/>
+          <a:lstStyle/>
+          <a:p>
+            <a:pPr algn="ctr"/>
+          </a:p>
+        </p:txBody>
+      </p:sp>
+      <p:sp>
+        <p:nvSpPr>
+          <p:cNvPr id="9" name="TextBox 8"/>
+          <p:cNvSpPr txBox="1"/>
+          <p:nvPr/>
+        </p:nvSpPr>
+        <p:spPr>
+          <a:xfrm>
+            <a:off x="6629400" y="1783080"/>
+            <a:ext cx="4617720" cy="4434840"/>
+          </a:xfrm>
+          <a:prstGeom prst="rect">
+            <a:avLst/>
+          </a:prstGeom>
+          <a:noFill/>
+        </p:spPr>
+        <p:txBody>
+          <a:bodyPr wrap="square" lIns="0" tIns="0" rIns="0" bIns="0">
+            <a:spAutoFit/>
+          </a:bodyPr>
+          <a:lstStyle/>
+          <a:p>
+            <a:pPr>
+              <a:spcAft>
+                <a:spcPts val="1200"/>
+              </a:spcAft>
+              <a:defRPr sz="1600" b="1">
+                <a:solidFill>
+                  <a:srgbClr val="184C34"/>
+                </a:solidFill>
+              </a:defRPr>
+            </a:pPr>
+            <a:r>
               <a:t>Performa Produk &amp; Pembeli (KPI 3, 4, 5)</a:t>
             </a:r>
           </a:p>
           <a:p>
             <a:pPr>
               <a:spcAft>
-                <a:spcPts val="500"/>
-              </a:spcAft>
-              <a:defRPr sz="1150">
+                <a:spcPts val="1000"/>
+              </a:spcAft>
+              <a:defRPr sz="1600">
                 <a:solidFill>
                   <a:srgbClr val="212529"/>
                 </a:solidFill>
@@ -5909,9 +6466,9 @@
           <a:p>
             <a:pPr>
               <a:spcAft>
-                <a:spcPts val="500"/>
-              </a:spcAft>
-              <a:defRPr sz="1150">
+                <a:spcPts val="1000"/>
+              </a:spcAft>
+              <a:defRPr sz="1600">
                 <a:solidFill>
                   <a:srgbClr val="212529"/>
                 </a:solidFill>
@@ -5922,15 +6479,15 @@
             </a:r>
             <a:br/>
             <a:r>
-              <a:t>Melon Lavender (860 buah), Pete (487 ikat), dan Tomat Cherry (372 kg).</a:t>
-            </a:r>
-          </a:p>
-          <a:p>
-            <a:pPr>
-              <a:spcAft>
-                <a:spcPts val="500"/>
-              </a:spcAft>
-              <a:defRPr sz="1150">
+              <a:t>Melon Sweet Lavender (860 kg), Pete (487 pack), dan Tomat Cherry (372,5 kg).</a:t>
+            </a:r>
+          </a:p>
+          <a:p>
+            <a:pPr>
+              <a:spcAft>
+                <a:spcPts val="1000"/>
+              </a:spcAft>
+              <a:defRPr sz="1600">
                 <a:solidFill>
                   <a:srgbClr val="212529"/>
                 </a:solidFill>
@@ -6066,7 +6623,7 @@
       </p:sp>
       <p:sp>
         <p:nvSpPr>
-          <p:cNvPr id="4" name="Rounded Rectangle 3"/>
+          <p:cNvPr id="4" name="Rectangle 3"/>
           <p:cNvSpPr/>
           <p:nvPr/>
         </p:nvSpPr>
@@ -6075,15 +6632,15 @@
             <a:off x="731520" y="1554480"/>
             <a:ext cx="5120640" cy="4846320"/>
           </a:xfrm>
-          <a:prstGeom prst="roundRect">
+          <a:prstGeom prst="rect">
             <a:avLst/>
           </a:prstGeom>
           <a:solidFill>
-            <a:srgbClr val="FFFFFF"/>
+            <a:srgbClr val="F8F9FA"/>
           </a:solidFill>
-          <a:ln w="19050">
+          <a:ln w="9525">
             <a:solidFill>
-              <a:srgbClr val="35865B"/>
+              <a:srgbClr val="DEE2E6"/>
             </a:solidFill>
           </a:ln>
         </p:spPr>
@@ -6111,108 +6668,23 @@
       </p:sp>
       <p:sp>
         <p:nvSpPr>
-          <p:cNvPr id="5" name="TextBox 4"/>
-          <p:cNvSpPr txBox="1"/>
-          <p:nvPr/>
-        </p:nvSpPr>
-        <p:spPr>
-          <a:xfrm>
-            <a:off x="932688" y="1719072"/>
-            <a:ext cx="4718304" cy="4517136"/>
-          </a:xfrm>
-          <a:prstGeom prst="rect">
-            <a:avLst/>
-          </a:prstGeom>
-          <a:noFill/>
-        </p:spPr>
-        <p:txBody>
-          <a:bodyPr wrap="square" lIns="0" tIns="0" rIns="0" bIns="0">
-            <a:spAutoFit/>
-          </a:bodyPr>
-          <a:lstStyle/>
-          <a:p>
-            <a:pPr>
-              <a:spcAft>
-                <a:spcPts val="800"/>
-              </a:spcAft>
-              <a:defRPr sz="1400" b="1">
-                <a:solidFill>
-                  <a:srgbClr val="184C34"/>
-                </a:solidFill>
-              </a:defRPr>
-            </a:pPr>
-            <a:r>
-              <a:t>Efek Pareto 80/20 Portofolio Produk</a:t>
-            </a:r>
-          </a:p>
-          <a:p>
-            <a:pPr>
-              <a:spcAft>
-                <a:spcPts val="500"/>
-              </a:spcAft>
-              <a:defRPr sz="1150">
-                <a:solidFill>
-                  <a:srgbClr val="212529"/>
-                </a:solidFill>
-              </a:defRPr>
-            </a:pPr>
-            <a:r>
-              <a:t>• Hanya 2 dari 16 komoditas (Melon Sweet Lavender dan Tomat Cherry) menyumbang 80,6% dari seluruh total omzet kebun BBPP Ketindan.</a:t>
-            </a:r>
-          </a:p>
-          <a:p>
-            <a:pPr>
-              <a:spcAft>
-                <a:spcPts val="500"/>
-              </a:spcAft>
-              <a:defRPr sz="1150">
-                <a:solidFill>
-                  <a:srgbClr val="212529"/>
-                </a:solidFill>
-              </a:defRPr>
-            </a:pPr>
-            <a:r>
-              <a:t>• 14 komoditas lainnya (sawi, selada, kimpul, kenikir) menyumbang 19,4% omzet, namun berfungsi menjaga arus kas harian dan perputaran cepat di pasar lokal.</a:t>
-            </a:r>
-          </a:p>
-          <a:p>
-            <a:pPr>
-              <a:spcAft>
-                <a:spcPts val="500"/>
-              </a:spcAft>
-              <a:defRPr sz="1150">
-                <a:solidFill>
-                  <a:srgbClr val="212529"/>
-                </a:solidFill>
-              </a:defRPr>
-            </a:pPr>
-            <a:r>
-              <a:t>• Produktivitas Lahan: Blok PROGEV dan Greenhouse (SGH) menghasilkan margin moneter tertinggi per meter persegi lahan.</a:t>
-            </a:r>
-          </a:p>
-        </p:txBody>
-      </p:sp>
-      <p:sp>
-        <p:nvSpPr>
-          <p:cNvPr id="6" name="Rounded Rectangle 5"/>
+          <p:cNvPr id="5" name="Rectangle 4"/>
           <p:cNvSpPr/>
           <p:nvPr/>
         </p:nvSpPr>
         <p:spPr>
           <a:xfrm>
-            <a:off x="6309360" y="1554480"/>
-            <a:ext cx="5120640" cy="4846320"/>
-          </a:xfrm>
-          <a:prstGeom prst="roundRect">
+            <a:off x="731520" y="1554480"/>
+            <a:ext cx="73152" cy="4846320"/>
+          </a:xfrm>
+          <a:prstGeom prst="rect">
             <a:avLst/>
           </a:prstGeom>
           <a:solidFill>
-            <a:srgbClr val="FFFFFF"/>
+            <a:srgbClr val="35865B"/>
           </a:solidFill>
-          <a:ln w="19050">
-            <a:solidFill>
-              <a:srgbClr val="35865B"/>
-            </a:solidFill>
+          <a:ln>
+            <a:noFill/>
           </a:ln>
         </p:spPr>
         <p:style>
@@ -6239,14 +6711,14 @@
       </p:sp>
       <p:sp>
         <p:nvSpPr>
-          <p:cNvPr id="7" name="TextBox 6"/>
+          <p:cNvPr id="6" name="TextBox 5"/>
           <p:cNvSpPr txBox="1"/>
           <p:nvPr/>
         </p:nvSpPr>
         <p:spPr>
           <a:xfrm>
-            <a:off x="6510528" y="1719072"/>
-            <a:ext cx="4718304" cy="4517136"/>
+            <a:off x="1051560" y="1783080"/>
+            <a:ext cx="4617720" cy="4434840"/>
           </a:xfrm>
           <a:prstGeom prst="rect">
             <a:avLst/>
@@ -6261,39 +6733,210 @@
           <a:p>
             <a:pPr>
               <a:spcAft>
-                <a:spcPts val="800"/>
-              </a:spcAft>
-              <a:defRPr sz="1400" b="1">
+                <a:spcPts val="1200"/>
+              </a:spcAft>
+              <a:defRPr sz="1600" b="1">
                 <a:solidFill>
                   <a:srgbClr val="184C34"/>
                 </a:solidFill>
               </a:defRPr>
             </a:pPr>
             <a:r>
+              <a:t>Efek Pareto 80/20 Portofolio Produk</a:t>
+            </a:r>
+          </a:p>
+          <a:p>
+            <a:pPr>
+              <a:spcAft>
+                <a:spcPts val="1000"/>
+              </a:spcAft>
+              <a:defRPr sz="1600">
+                <a:solidFill>
+                  <a:srgbClr val="212529"/>
+                </a:solidFill>
+              </a:defRPr>
+            </a:pPr>
+            <a:r>
+              <a:t>• Hanya 2 dari 16 komoditas (Melon Sweet Lavender dan Tomat Cherry) menyumbang 80,6% dari seluruh total omzet kebun BBPP Ketindan.</a:t>
+            </a:r>
+          </a:p>
+          <a:p>
+            <a:pPr>
+              <a:spcAft>
+                <a:spcPts val="1000"/>
+              </a:spcAft>
+              <a:defRPr sz="1600">
+                <a:solidFill>
+                  <a:srgbClr val="212529"/>
+                </a:solidFill>
+              </a:defRPr>
+            </a:pPr>
+            <a:r>
+              <a:t>• 14 komoditas lainnya (sawi, selada, kimpul, kenikir) menyumbang 19,4% omzet, namun berfungsi menjaga arus kas harian dan perputaran cepat di pasar lokal.</a:t>
+            </a:r>
+          </a:p>
+          <a:p>
+            <a:pPr>
+              <a:spcAft>
+                <a:spcPts val="1000"/>
+              </a:spcAft>
+              <a:defRPr sz="1600">
+                <a:solidFill>
+                  <a:srgbClr val="212529"/>
+                </a:solidFill>
+              </a:defRPr>
+            </a:pPr>
+            <a:r>
+              <a:t>• Konsentrasi Lahan: Smart Greenhouse (SGH) menghasilkan Rp 26,33 Jt (88,3% omzet), lahan UMUM 10,5%, sedangkan PP, P3K, dan PROGEV gabungan kurang dari 1,2%.</a:t>
+            </a:r>
+          </a:p>
+        </p:txBody>
+      </p:sp>
+      <p:sp>
+        <p:nvSpPr>
+          <p:cNvPr id="7" name="Rectangle 6"/>
+          <p:cNvSpPr/>
+          <p:nvPr/>
+        </p:nvSpPr>
+        <p:spPr>
+          <a:xfrm>
+            <a:off x="6309360" y="1554480"/>
+            <a:ext cx="5120640" cy="4846320"/>
+          </a:xfrm>
+          <a:prstGeom prst="rect">
+            <a:avLst/>
+          </a:prstGeom>
+          <a:solidFill>
+            <a:srgbClr val="F8F9FA"/>
+          </a:solidFill>
+          <a:ln w="9525">
+            <a:solidFill>
+              <a:srgbClr val="DEE2E6"/>
+            </a:solidFill>
+          </a:ln>
+        </p:spPr>
+        <p:style>
+          <a:lnRef idx="1">
+            <a:schemeClr val="accent1"/>
+          </a:lnRef>
+          <a:fillRef idx="3">
+            <a:schemeClr val="accent1"/>
+          </a:fillRef>
+          <a:effectRef idx="2">
+            <a:schemeClr val="accent1"/>
+          </a:effectRef>
+          <a:fontRef idx="minor">
+            <a:schemeClr val="lt1"/>
+          </a:fontRef>
+        </p:style>
+        <p:txBody>
+          <a:bodyPr rtlCol="0" anchor="ctr"/>
+          <a:lstStyle/>
+          <a:p>
+            <a:pPr algn="ctr"/>
+          </a:p>
+        </p:txBody>
+      </p:sp>
+      <p:sp>
+        <p:nvSpPr>
+          <p:cNvPr id="8" name="Rectangle 7"/>
+          <p:cNvSpPr/>
+          <p:nvPr/>
+        </p:nvSpPr>
+        <p:spPr>
+          <a:xfrm>
+            <a:off x="6309360" y="1554480"/>
+            <a:ext cx="73152" cy="4846320"/>
+          </a:xfrm>
+          <a:prstGeom prst="rect">
+            <a:avLst/>
+          </a:prstGeom>
+          <a:solidFill>
+            <a:srgbClr val="35865B"/>
+          </a:solidFill>
+          <a:ln>
+            <a:noFill/>
+          </a:ln>
+        </p:spPr>
+        <p:style>
+          <a:lnRef idx="1">
+            <a:schemeClr val="accent1"/>
+          </a:lnRef>
+          <a:fillRef idx="3">
+            <a:schemeClr val="accent1"/>
+          </a:fillRef>
+          <a:effectRef idx="2">
+            <a:schemeClr val="accent1"/>
+          </a:effectRef>
+          <a:fontRef idx="minor">
+            <a:schemeClr val="lt1"/>
+          </a:fontRef>
+        </p:style>
+        <p:txBody>
+          <a:bodyPr rtlCol="0" anchor="ctr"/>
+          <a:lstStyle/>
+          <a:p>
+            <a:pPr algn="ctr"/>
+          </a:p>
+        </p:txBody>
+      </p:sp>
+      <p:sp>
+        <p:nvSpPr>
+          <p:cNvPr id="9" name="TextBox 8"/>
+          <p:cNvSpPr txBox="1"/>
+          <p:nvPr/>
+        </p:nvSpPr>
+        <p:spPr>
+          <a:xfrm>
+            <a:off x="6629400" y="1783080"/>
+            <a:ext cx="4617720" cy="4434840"/>
+          </a:xfrm>
+          <a:prstGeom prst="rect">
+            <a:avLst/>
+          </a:prstGeom>
+          <a:noFill/>
+        </p:spPr>
+        <p:txBody>
+          <a:bodyPr wrap="square" lIns="0" tIns="0" rIns="0" bIns="0">
+            <a:spAutoFit/>
+          </a:bodyPr>
+          <a:lstStyle/>
+          <a:p>
+            <a:pPr>
+              <a:spcAft>
+                <a:spcPts val="1200"/>
+              </a:spcAft>
+              <a:defRPr sz="1600" b="1">
+                <a:solidFill>
+                  <a:srgbClr val="184C34"/>
+                </a:solidFill>
+              </a:defRPr>
+            </a:pPr>
+            <a:r>
               <a:t>Karakteristik Pembeli &amp; Kerentanan Pasar</a:t>
             </a:r>
           </a:p>
           <a:p>
             <a:pPr>
               <a:spcAft>
-                <a:spcPts val="500"/>
-              </a:spcAft>
-              <a:defRPr sz="1150">
+                <a:spcPts val="1000"/>
+              </a:spcAft>
+              <a:defRPr sz="1600">
                 <a:solidFill>
                   <a:srgbClr val="212529"/>
                 </a:solidFill>
               </a:defRPr>
             </a:pPr>
             <a:r>
-              <a:t>• Distribusi Pembeli Tidak Seimbang: Mayoritas (212 pembeli) adalah pembeli ritel bernilai belanja kecil (Rp 10.000 - Rp 300.000).</a:t>
-            </a:r>
-          </a:p>
-          <a:p>
-            <a:pPr>
-              <a:spcAft>
-                <a:spcPts val="500"/>
-              </a:spcAft>
-              <a:defRPr sz="1150">
+              <a:t>• Distribusi Pembeli Tidak Seimbang: 193 dari 214 pembeli (90%) berbelanja total di bawah Rp 300.000 selama 8 minggu, sementara 2 pembeli grosir teratas menyerap 18,7% omzet.</a:t>
+            </a:r>
+          </a:p>
+          <a:p>
+            <a:pPr>
+              <a:spcAft>
+                <a:spcPts val="1000"/>
+              </a:spcAft>
+              <a:defRPr sz="1600">
                 <a:solidFill>
                   <a:srgbClr val="212529"/>
                 </a:solidFill>
@@ -6306,9 +6949,9 @@
           <a:p>
             <a:pPr>
               <a:spcAft>
-                <a:spcPts val="500"/>
-              </a:spcAft>
-              <a:defRPr sz="1150">
+                <a:spcPts val="1000"/>
+              </a:spcAft>
+              <a:defRPr sz="1600">
                 <a:solidFill>
                   <a:srgbClr val="212529"/>
                 </a:solidFill>
@@ -6432,7 +7075,7 @@
       </p:sp>
       <p:sp>
         <p:nvSpPr>
-          <p:cNvPr id="4" name="Rounded Rectangle 3"/>
+          <p:cNvPr id="4" name="Rectangle 3"/>
           <p:cNvSpPr/>
           <p:nvPr/>
         </p:nvSpPr>
@@ -6441,15 +7084,15 @@
             <a:off x="731520" y="1554480"/>
             <a:ext cx="3383280" cy="4846320"/>
           </a:xfrm>
-          <a:prstGeom prst="roundRect">
+          <a:prstGeom prst="rect">
             <a:avLst/>
           </a:prstGeom>
           <a:solidFill>
-            <a:srgbClr val="FFFFFF"/>
+            <a:srgbClr val="F8F9FA"/>
           </a:solidFill>
-          <a:ln w="19050">
+          <a:ln w="9525">
             <a:solidFill>
-              <a:srgbClr val="35865B"/>
+              <a:srgbClr val="DEE2E6"/>
             </a:solidFill>
           </a:ln>
         </p:spPr>
@@ -6477,108 +7120,23 @@
       </p:sp>
       <p:sp>
         <p:nvSpPr>
-          <p:cNvPr id="5" name="TextBox 4"/>
-          <p:cNvSpPr txBox="1"/>
-          <p:nvPr/>
-        </p:nvSpPr>
-        <p:spPr>
-          <a:xfrm>
-            <a:off x="932688" y="1719072"/>
-            <a:ext cx="2980944" cy="4517136"/>
-          </a:xfrm>
-          <a:prstGeom prst="rect">
-            <a:avLst/>
-          </a:prstGeom>
-          <a:noFill/>
-        </p:spPr>
-        <p:txBody>
-          <a:bodyPr wrap="square" lIns="0" tIns="0" rIns="0" bIns="0">
-            <a:spAutoFit/>
-          </a:bodyPr>
-          <a:lstStyle/>
-          <a:p>
-            <a:pPr>
-              <a:spcAft>
-                <a:spcPts val="800"/>
-              </a:spcAft>
-              <a:defRPr sz="1400" b="1">
-                <a:solidFill>
-                  <a:srgbClr val="184C34"/>
-                </a:solidFill>
-              </a:defRPr>
-            </a:pPr>
-            <a:r>
-              <a:t>1. Penjadwalan Tanam Bergilir</a:t>
-            </a:r>
-          </a:p>
-          <a:p>
-            <a:pPr>
-              <a:spcAft>
-                <a:spcPts val="500"/>
-              </a:spcAft>
-              <a:defRPr sz="1150">
-                <a:solidFill>
-                  <a:srgbClr val="212529"/>
-                </a:solidFill>
-              </a:defRPr>
-            </a:pPr>
-            <a:r>
-              <a:t>• Terapkan sistem Staggered Planting pada Melon Sweet Lavender.</a:t>
-            </a:r>
-          </a:p>
-          <a:p>
-            <a:pPr>
-              <a:spcAft>
-                <a:spcPts val="500"/>
-              </a:spcAft>
-              <a:defRPr sz="1150">
-                <a:solidFill>
-                  <a:srgbClr val="212529"/>
-                </a:solidFill>
-              </a:defRPr>
-            </a:pPr>
-            <a:r>
-              <a:t>• Hindari penanaman serentak 100% yang memicu panen menumpuk di Minggu ke-36.</a:t>
-            </a:r>
-          </a:p>
-          <a:p>
-            <a:pPr>
-              <a:spcAft>
-                <a:spcPts val="500"/>
-              </a:spcAft>
-              <a:defRPr sz="1150">
-                <a:solidFill>
-                  <a:srgbClr val="212529"/>
-                </a:solidFill>
-              </a:defRPr>
-            </a:pPr>
-            <a:r>
-              <a:t>• Bagi penanaman ke dalam interval 1-2 minggu agar pasokan melon tersebar rata dan harga jual tetap stabil.</a:t>
-            </a:r>
-          </a:p>
-        </p:txBody>
-      </p:sp>
-      <p:sp>
-        <p:nvSpPr>
-          <p:cNvPr id="6" name="Rounded Rectangle 5"/>
+          <p:cNvPr id="5" name="Rectangle 4"/>
           <p:cNvSpPr/>
           <p:nvPr/>
         </p:nvSpPr>
         <p:spPr>
           <a:xfrm>
-            <a:off x="4389120" y="1554480"/>
-            <a:ext cx="3383280" cy="4846320"/>
-          </a:xfrm>
-          <a:prstGeom prst="roundRect">
+            <a:off x="731520" y="1554480"/>
+            <a:ext cx="73152" cy="4846320"/>
+          </a:xfrm>
+          <a:prstGeom prst="rect">
             <a:avLst/>
           </a:prstGeom>
           <a:solidFill>
-            <a:srgbClr val="FFFFFF"/>
+            <a:srgbClr val="35865B"/>
           </a:solidFill>
-          <a:ln w="19050">
-            <a:solidFill>
-              <a:srgbClr val="35865B"/>
-            </a:solidFill>
+          <a:ln>
+            <a:noFill/>
           </a:ln>
         </p:spPr>
         <p:style>
@@ -6605,14 +7163,14 @@
       </p:sp>
       <p:sp>
         <p:nvSpPr>
-          <p:cNvPr id="7" name="TextBox 6"/>
+          <p:cNvPr id="6" name="TextBox 5"/>
           <p:cNvSpPr txBox="1"/>
           <p:nvPr/>
         </p:nvSpPr>
         <p:spPr>
           <a:xfrm>
-            <a:off x="4590288" y="1719072"/>
-            <a:ext cx="2980944" cy="4517136"/>
+            <a:off x="1051560" y="1783080"/>
+            <a:ext cx="2880360" cy="4434840"/>
           </a:xfrm>
           <a:prstGeom prst="rect">
             <a:avLst/>
@@ -6627,85 +7185,85 @@
           <a:p>
             <a:pPr>
               <a:spcAft>
-                <a:spcPts val="800"/>
-              </a:spcAft>
-              <a:defRPr sz="1400" b="1">
+                <a:spcPts val="1200"/>
+              </a:spcAft>
+              <a:defRPr sz="1600" b="1">
                 <a:solidFill>
                   <a:srgbClr val="184C34"/>
                 </a:solidFill>
               </a:defRPr>
             </a:pPr>
             <a:r>
-              <a:t>2. Kontrak Kemitraan B2B</a:t>
-            </a:r>
-          </a:p>
-          <a:p>
-            <a:pPr>
-              <a:spcAft>
-                <a:spcPts val="500"/>
-              </a:spcAft>
-              <a:defRPr sz="1150">
+              <a:t>1. Penjadwalan Tanam Bergilir</a:t>
+            </a:r>
+          </a:p>
+          <a:p>
+            <a:pPr>
+              <a:spcAft>
+                <a:spcPts val="1000"/>
+              </a:spcAft>
+              <a:defRPr sz="1600">
                 <a:solidFill>
                   <a:srgbClr val="212529"/>
                 </a:solidFill>
               </a:defRPr>
             </a:pPr>
             <a:r>
-              <a:t>• Bangun perjanjian Offtaker Pre-order dengan pembeli kunci (B Rara &amp; P Joni).</a:t>
-            </a:r>
-          </a:p>
-          <a:p>
-            <a:pPr>
-              <a:spcAft>
-                <a:spcPts val="500"/>
-              </a:spcAft>
-              <a:defRPr sz="1150">
+              <a:t>• Terapkan sistem Staggered Planting pada Melon Sweet Lavender.</a:t>
+            </a:r>
+          </a:p>
+          <a:p>
+            <a:pPr>
+              <a:spcAft>
+                <a:spcPts val="1000"/>
+              </a:spcAft>
+              <a:defRPr sz="1600">
                 <a:solidFill>
                   <a:srgbClr val="212529"/>
                 </a:solidFill>
               </a:defRPr>
             </a:pPr>
             <a:r>
-              <a:t>• Terapkan deposit/uang muka sebelum panen untuk menjamin serapan buah Grade A.</a:t>
-            </a:r>
-          </a:p>
-          <a:p>
-            <a:pPr>
-              <a:spcAft>
-                <a:spcPts val="500"/>
-              </a:spcAft>
-              <a:defRPr sz="1150">
+              <a:t>• Hindari penanaman serentak 100% yang memicu panen menumpuk di Minggu ke-36.</a:t>
+            </a:r>
+          </a:p>
+          <a:p>
+            <a:pPr>
+              <a:spcAft>
+                <a:spcPts val="1000"/>
+              </a:spcAft>
+              <a:defRPr sz="1600">
                 <a:solidFill>
                   <a:srgbClr val="212529"/>
                 </a:solidFill>
               </a:defRPr>
             </a:pPr>
             <a:r>
-              <a:t>• Tawarkan sistem bundling untuk komoditas pendamping seperti Tomat Cherry dan sayuran segar.</a:t>
-            </a:r>
-          </a:p>
-        </p:txBody>
-      </p:sp>
-      <p:sp>
-        <p:nvSpPr>
-          <p:cNvPr id="8" name="Rounded Rectangle 7"/>
+              <a:t>• Bagi penanaman ke dalam interval 1-2 minggu agar pasokan melon tersebar rata dan harga jual tetap stabil.</a:t>
+            </a:r>
+          </a:p>
+        </p:txBody>
+      </p:sp>
+      <p:sp>
+        <p:nvSpPr>
+          <p:cNvPr id="7" name="Rectangle 6"/>
           <p:cNvSpPr/>
           <p:nvPr/>
         </p:nvSpPr>
         <p:spPr>
           <a:xfrm>
-            <a:off x="8046720" y="1554480"/>
+            <a:off x="4389120" y="1554480"/>
             <a:ext cx="3383280" cy="4846320"/>
           </a:xfrm>
-          <a:prstGeom prst="roundRect">
+          <a:prstGeom prst="rect">
             <a:avLst/>
           </a:prstGeom>
           <a:solidFill>
-            <a:srgbClr val="FFFFFF"/>
+            <a:srgbClr val="F8F9FA"/>
           </a:solidFill>
-          <a:ln w="19050">
+          <a:ln w="9525">
             <a:solidFill>
-              <a:srgbClr val="35865B"/>
+              <a:srgbClr val="DEE2E6"/>
             </a:solidFill>
           </a:ln>
         </p:spPr>
@@ -6733,14 +7291,57 @@
       </p:sp>
       <p:sp>
         <p:nvSpPr>
+          <p:cNvPr id="8" name="Rectangle 7"/>
+          <p:cNvSpPr/>
+          <p:nvPr/>
+        </p:nvSpPr>
+        <p:spPr>
+          <a:xfrm>
+            <a:off x="4389120" y="1554480"/>
+            <a:ext cx="73152" cy="4846320"/>
+          </a:xfrm>
+          <a:prstGeom prst="rect">
+            <a:avLst/>
+          </a:prstGeom>
+          <a:solidFill>
+            <a:srgbClr val="35865B"/>
+          </a:solidFill>
+          <a:ln>
+            <a:noFill/>
+          </a:ln>
+        </p:spPr>
+        <p:style>
+          <a:lnRef idx="1">
+            <a:schemeClr val="accent1"/>
+          </a:lnRef>
+          <a:fillRef idx="3">
+            <a:schemeClr val="accent1"/>
+          </a:fillRef>
+          <a:effectRef idx="2">
+            <a:schemeClr val="accent1"/>
+          </a:effectRef>
+          <a:fontRef idx="minor">
+            <a:schemeClr val="lt1"/>
+          </a:fontRef>
+        </p:style>
+        <p:txBody>
+          <a:bodyPr rtlCol="0" anchor="ctr"/>
+          <a:lstStyle/>
+          <a:p>
+            <a:pPr algn="ctr"/>
+          </a:p>
+        </p:txBody>
+      </p:sp>
+      <p:sp>
+        <p:nvSpPr>
           <p:cNvPr id="9" name="TextBox 8"/>
           <p:cNvSpPr txBox="1"/>
           <p:nvPr/>
         </p:nvSpPr>
         <p:spPr>
           <a:xfrm>
-            <a:off x="8247888" y="1719072"/>
-            <a:ext cx="2980944" cy="4517136"/>
+            <a:off x="4709160" y="1783080"/>
+            <a:ext cx="2880360" cy="4434840"/>
           </a:xfrm>
           <a:prstGeom prst="rect">
             <a:avLst/>
@@ -6755,54 +7356,225 @@
           <a:p>
             <a:pPr>
               <a:spcAft>
-                <a:spcPts val="800"/>
-              </a:spcAft>
-              <a:defRPr sz="1400" b="1">
+                <a:spcPts val="1200"/>
+              </a:spcAft>
+              <a:defRPr sz="1600" b="1">
                 <a:solidFill>
                   <a:srgbClr val="184C34"/>
                 </a:solidFill>
               </a:defRPr>
             </a:pPr>
             <a:r>
+              <a:t>2. Kontrak Kemitraan B2B</a:t>
+            </a:r>
+          </a:p>
+          <a:p>
+            <a:pPr>
+              <a:spcAft>
+                <a:spcPts val="1000"/>
+              </a:spcAft>
+              <a:defRPr sz="1600">
+                <a:solidFill>
+                  <a:srgbClr val="212529"/>
+                </a:solidFill>
+              </a:defRPr>
+            </a:pPr>
+            <a:r>
+              <a:t>• Bangun perjanjian Offtaker Pre-order dengan pembeli kunci (B Rara &amp; P Joni).</a:t>
+            </a:r>
+          </a:p>
+          <a:p>
+            <a:pPr>
+              <a:spcAft>
+                <a:spcPts val="1000"/>
+              </a:spcAft>
+              <a:defRPr sz="1600">
+                <a:solidFill>
+                  <a:srgbClr val="212529"/>
+                </a:solidFill>
+              </a:defRPr>
+            </a:pPr>
+            <a:r>
+              <a:t>• Terapkan deposit/uang muka sebelum panen untuk menjamin serapan buah Grade A.</a:t>
+            </a:r>
+          </a:p>
+          <a:p>
+            <a:pPr>
+              <a:spcAft>
+                <a:spcPts val="1000"/>
+              </a:spcAft>
+              <a:defRPr sz="1600">
+                <a:solidFill>
+                  <a:srgbClr val="212529"/>
+                </a:solidFill>
+              </a:defRPr>
+            </a:pPr>
+            <a:r>
+              <a:t>• Tawarkan sistem bundling untuk komoditas pendamping seperti Tomat Cherry dan sayuran segar.</a:t>
+            </a:r>
+          </a:p>
+        </p:txBody>
+      </p:sp>
+      <p:sp>
+        <p:nvSpPr>
+          <p:cNvPr id="10" name="Rectangle 9"/>
+          <p:cNvSpPr/>
+          <p:nvPr/>
+        </p:nvSpPr>
+        <p:spPr>
+          <a:xfrm>
+            <a:off x="8046720" y="1554480"/>
+            <a:ext cx="3383280" cy="4846320"/>
+          </a:xfrm>
+          <a:prstGeom prst="rect">
+            <a:avLst/>
+          </a:prstGeom>
+          <a:solidFill>
+            <a:srgbClr val="F8F9FA"/>
+          </a:solidFill>
+          <a:ln w="9525">
+            <a:solidFill>
+              <a:srgbClr val="DEE2E6"/>
+            </a:solidFill>
+          </a:ln>
+        </p:spPr>
+        <p:style>
+          <a:lnRef idx="1">
+            <a:schemeClr val="accent1"/>
+          </a:lnRef>
+          <a:fillRef idx="3">
+            <a:schemeClr val="accent1"/>
+          </a:fillRef>
+          <a:effectRef idx="2">
+            <a:schemeClr val="accent1"/>
+          </a:effectRef>
+          <a:fontRef idx="minor">
+            <a:schemeClr val="lt1"/>
+          </a:fontRef>
+        </p:style>
+        <p:txBody>
+          <a:bodyPr rtlCol="0" anchor="ctr"/>
+          <a:lstStyle/>
+          <a:p>
+            <a:pPr algn="ctr"/>
+          </a:p>
+        </p:txBody>
+      </p:sp>
+      <p:sp>
+        <p:nvSpPr>
+          <p:cNvPr id="11" name="Rectangle 10"/>
+          <p:cNvSpPr/>
+          <p:nvPr/>
+        </p:nvSpPr>
+        <p:spPr>
+          <a:xfrm>
+            <a:off x="8046720" y="1554480"/>
+            <a:ext cx="73152" cy="4846320"/>
+          </a:xfrm>
+          <a:prstGeom prst="rect">
+            <a:avLst/>
+          </a:prstGeom>
+          <a:solidFill>
+            <a:srgbClr val="35865B"/>
+          </a:solidFill>
+          <a:ln>
+            <a:noFill/>
+          </a:ln>
+        </p:spPr>
+        <p:style>
+          <a:lnRef idx="1">
+            <a:schemeClr val="accent1"/>
+          </a:lnRef>
+          <a:fillRef idx="3">
+            <a:schemeClr val="accent1"/>
+          </a:fillRef>
+          <a:effectRef idx="2">
+            <a:schemeClr val="accent1"/>
+          </a:effectRef>
+          <a:fontRef idx="minor">
+            <a:schemeClr val="lt1"/>
+          </a:fontRef>
+        </p:style>
+        <p:txBody>
+          <a:bodyPr rtlCol="0" anchor="ctr"/>
+          <a:lstStyle/>
+          <a:p>
+            <a:pPr algn="ctr"/>
+          </a:p>
+        </p:txBody>
+      </p:sp>
+      <p:sp>
+        <p:nvSpPr>
+          <p:cNvPr id="12" name="TextBox 11"/>
+          <p:cNvSpPr txBox="1"/>
+          <p:nvPr/>
+        </p:nvSpPr>
+        <p:spPr>
+          <a:xfrm>
+            <a:off x="8366760" y="1783080"/>
+            <a:ext cx="2880360" cy="4434840"/>
+          </a:xfrm>
+          <a:prstGeom prst="rect">
+            <a:avLst/>
+          </a:prstGeom>
+          <a:noFill/>
+        </p:spPr>
+        <p:txBody>
+          <a:bodyPr wrap="square" lIns="0" tIns="0" rIns="0" bIns="0">
+            <a:spAutoFit/>
+          </a:bodyPr>
+          <a:lstStyle/>
+          <a:p>
+            <a:pPr>
+              <a:spcAft>
+                <a:spcPts val="1200"/>
+              </a:spcAft>
+              <a:defRPr sz="1600" b="1">
+                <a:solidFill>
+                  <a:srgbClr val="184C34"/>
+                </a:solidFill>
+              </a:defRPr>
+            </a:pPr>
+            <a:r>
               <a:t>3. Optimasi Alokasi Lahan</a:t>
             </a:r>
           </a:p>
           <a:p>
             <a:pPr>
               <a:spcAft>
-                <a:spcPts val="500"/>
-              </a:spcAft>
-              <a:defRPr sz="1150">
+                <a:spcPts val="1000"/>
+              </a:spcAft>
+              <a:defRPr sz="1600">
                 <a:solidFill>
                   <a:srgbClr val="212529"/>
                 </a:solidFill>
               </a:defRPr>
             </a:pPr>
             <a:r>
-              <a:t>• Prioritaskan fasilitas Smart Greenhouse (SGH &amp; PROGEV) khusus untuk varietas komersial bernilai tinggi.</a:t>
-            </a:r>
-          </a:p>
-          <a:p>
-            <a:pPr>
-              <a:spcAft>
-                <a:spcPts val="500"/>
-              </a:spcAft>
-              <a:defRPr sz="1150">
+              <a:t>• Pertahankan Smart Greenhouse (SGH), sumber 88,3% omzet, khusus untuk varietas bernilai tinggi (Melon &amp; Tomat Cherry).</a:t>
+            </a:r>
+          </a:p>
+          <a:p>
+            <a:pPr>
+              <a:spcAft>
+                <a:spcPts val="1000"/>
+              </a:spcAft>
+              <a:defRPr sz="1600">
                 <a:solidFill>
                   <a:srgbClr val="212529"/>
                 </a:solidFill>
               </a:defRPr>
             </a:pPr>
             <a:r>
-              <a:t>• Lahan terbuka (PP/UMUM) dimaksimalkan untuk tanaman cepat panen berbiaya operasional rendah.</a:t>
-            </a:r>
-          </a:p>
-          <a:p>
-            <a:pPr>
-              <a:spcAft>
-                <a:spcPts val="500"/>
-              </a:spcAft>
-              <a:defRPr sz="1150">
+              <a:t>• Evaluasi pemanfaatan blok PP, P3K, dan PROGEV yang kontribusinya di bawah 1%: alihkan ke tanaman cepat panen berbiaya rendah.</a:t>
+            </a:r>
+          </a:p>
+          <a:p>
+            <a:pPr>
+              <a:spcAft>
+                <a:spcPts val="1000"/>
+              </a:spcAft>
+              <a:defRPr sz="1600">
                 <a:solidFill>
                   <a:srgbClr val="212529"/>
                 </a:solidFill>

</xml_diff>